<commit_message>
Extended presentation on research with governance and AI
</commit_message>
<xml_diff>
--- a/Work Group Guide/Source/Research Presentation.pptx
+++ b/Work Group Guide/Source/Research Presentation.pptx
@@ -5,7 +5,7 @@
     <p:sldMasterId id="2147483648" r:id="rId1"/>
   </p:sldMasterIdLst>
   <p:notesMasterIdLst>
-    <p:notesMasterId r:id="rId9"/>
+    <p:notesMasterId r:id="rId11"/>
   </p:notesMasterIdLst>
   <p:sldIdLst>
     <p:sldId id="256" r:id="rId2"/>
@@ -14,17 +14,17 @@
     <p:sldId id="259" r:id="rId5"/>
     <p:sldId id="260" r:id="rId6"/>
     <p:sldId id="261" r:id="rId7"/>
-    <p:sldId id="262" r:id="rId8"/>
+    <p:sldId id="263" r:id="rId8"/>
+    <p:sldId id="264" r:id="rId9"/>
+    <p:sldId id="262" r:id="rId10"/>
   </p:sldIdLst>
   <p:sldSz cx="12192000" cy="6858000"/>
   <p:notesSz cx="6858000" cy="12192000"/>
   <p:embeddedFontLst>
     <p:embeddedFont>
       <p:font typeface="IBM Plex Mono" panose="020B0509050203000203" pitchFamily="49" charset="0"/>
-      <p:regular r:id="rId10"/>
-      <p:bold r:id="rId11"/>
-      <p:italic r:id="rId12"/>
-      <p:boldItalic r:id="rId13"/>
+      <p:regular r:id="rId12"/>
+      <p:bold r:id="rId13"/>
     </p:embeddedFont>
     <p:embeddedFont>
       <p:font typeface="Inter"/>
@@ -831,7 +831,7 @@
           <a:p>
             <a:fld id="{F7021451-1387-4CA6-816F-3879F97B5CBC}" type="slidenum">
               <a:rPr lang="en-US"/>
-              <a:t>7</a:t>
+              <a:t>9</a:t>
             </a:fld>
             <a:endParaRPr lang="en-US"/>
           </a:p>
@@ -4537,7 +4537,7 @@
                 <a:ea typeface="IBM Plex Mono" pitchFamily="34" charset="-122"/>
                 <a:cs typeface="IBM Plex Mono" pitchFamily="34" charset="-120"/>
               </a:rPr>
-              <a:t>TOWARD HUMAN-CENTERED AI</a:t>
+              <a:t>HUMAN-CENTERED AI</a:t>
             </a:r>
             <a:endParaRPr lang="en-US" sz="1200" dirty="0"/>
           </a:p>
@@ -4579,7 +4579,7 @@
                 <a:ea typeface="Sora" pitchFamily="34" charset="-122"/>
                 <a:cs typeface="Sora" pitchFamily="34" charset="-120"/>
               </a:rPr>
-              <a:t>Human-centered AI keeps people in control, backed by real governance – not just principles.</a:t>
+              <a:t>Human-centered AI balances human control and automation, guided by shared values.</a:t>
             </a:r>
             <a:endParaRPr lang="en-US" sz="3200" dirty="0"/>
           </a:p>
@@ -4701,7 +4701,7 @@
                 <a:ea typeface="Inter"/>
                 <a:cs typeface="Inter"/>
               </a:rPr>
-              <a:t>Two dimensions. </a:t>
+              <a:t>One scale is not enough. </a:t>
             </a:r>
             <a:r>
               <a:rPr lang="en-US" sz="1300" dirty="0">
@@ -4712,7 +4712,7 @@
                 <a:ea typeface="Inter"/>
                 <a:cs typeface="Inter"/>
               </a:rPr>
-              <a:t>Human control and computer automation are separate axes, not a single scale. </a:t>
+              <a:t>Early models run from no automation to full autonomy, as in self-driving cars, and force a choice. Too much control or too much automation can both add risk. </a:t>
             </a:r>
             <a:r>
               <a:rPr lang="en-US" sz="1100" dirty="0">
@@ -4723,7 +4723,7 @@
                 <a:ea typeface="Inter"/>
                 <a:cs typeface="Inter"/>
               </a:rPr>
-              <a:t>(Shneiderman, 2020)</a:t>
+              <a:t>(Sheridan &amp; Verplank, 1978; SAE, 2014)</a:t>
             </a:r>
           </a:p>
         </p:txBody>
@@ -4805,7 +4805,7 @@
                 <a:ea typeface="Inter"/>
                 <a:cs typeface="Inter"/>
               </a:rPr>
-              <a:t>Copenhagen Manifesto. </a:t>
+              <a:t>Two dimensions. </a:t>
             </a:r>
             <a:r>
               <a:rPr lang="en-US" sz="1300" dirty="0">
@@ -4816,7 +4816,7 @@
                 <a:ea typeface="Inter"/>
                 <a:cs typeface="Inter"/>
               </a:rPr>
-              <a:t>35 scholars set five values and twelve principles built on dignity, autonomy and wellbeing. </a:t>
+              <a:t>Human control and computer automation are separate axes. Life-critical systems such as pacemakers and self-driving cars need both high to be reliable, safe and trustworthy. </a:t>
             </a:r>
             <a:r>
               <a:rPr lang="en-US" sz="1100" dirty="0">
@@ -4827,7 +4827,7 @@
                 <a:ea typeface="Inter"/>
                 <a:cs typeface="Inter"/>
               </a:rPr>
-              <a:t>(Russo et al., 2024)</a:t>
+              <a:t>(Shneiderman, 2020)</a:t>
             </a:r>
           </a:p>
         </p:txBody>
@@ -4909,7 +4909,7 @@
                 <a:ea typeface="Inter"/>
                 <a:cs typeface="Inter"/>
               </a:rPr>
-              <a:t>Working definition. </a:t>
+              <a:t>Copenhagen Manifesto. </a:t>
             </a:r>
             <a:r>
               <a:rPr lang="en-US" sz="1300" dirty="0">
@@ -4920,7 +4920,7 @@
                 <a:ea typeface="Inter"/>
                 <a:cs typeface="Inter"/>
               </a:rPr>
-              <a:t>Efficient work while people stay in control, motivated, connected, and free to question or reject AI decisions. </a:t>
+              <a:t>35 scholars set five values and twelve principles on human dignity, autonomy and collective wellbeing, including human sovereignty and responsible management. </a:t>
             </a:r>
             <a:r>
               <a:rPr lang="en-US" sz="1100" dirty="0">
@@ -4931,7 +4931,7 @@
                 <a:ea typeface="Inter"/>
                 <a:cs typeface="Inter"/>
               </a:rPr>
-              <a:t>(Initiative draft)</a:t>
+              <a:t>(Russo et al., 2024)</a:t>
             </a:r>
           </a:p>
         </p:txBody>
@@ -4998,6 +4998,12 @@
           <a:bodyPr wrap="square" rtlCol="0" anchor="t"/>
           <a:lstStyle/>
           <a:p>
+            <a:pPr marL="0" indent="0" algn="l">
+              <a:lnSpc>
+                <a:spcPct val="100000"/>
+              </a:lnSpc>
+              <a:buNone/>
+            </a:pPr>
             <a:r>
               <a:rPr lang="en-US" sz="1300" b="1" dirty="0">
                 <a:solidFill>
@@ -5007,7 +5013,7 @@
                 <a:ea typeface="Inter"/>
                 <a:cs typeface="Inter"/>
               </a:rPr>
-              <a:t>Governance gap. </a:t>
+              <a:t>Working definition. </a:t>
             </a:r>
             <a:r>
               <a:rPr lang="en-US" sz="1300" dirty="0">
@@ -5018,7 +5024,7 @@
                 <a:ea typeface="Inter"/>
                 <a:cs typeface="Inter"/>
               </a:rPr>
-              <a:t>Ethical guidelines say what, not how, and can lose to commercial interests. Structures and processes are needed. </a:t>
+              <a:t>No agreed definition yet. Our draft: efficient work while people stay in control, motivated, connected, and free to question, change or reject AI decisions. </a:t>
             </a:r>
             <a:r>
               <a:rPr lang="en-US" sz="1100" dirty="0">
@@ -5029,49 +5035,8 @@
                 <a:ea typeface="Inter"/>
                 <a:cs typeface="Inter"/>
               </a:rPr>
-              <a:t>(Mittelstadt, 2019; Mäntymäki et al., 2022). </a:t>
-            </a:r>
-            <a:r>
-              <a:rPr lang="en-US" sz="1300" dirty="0">
-                <a:solidFill>
-                  <a:srgbClr val="33424D"/>
-                </a:solidFill>
-                <a:latin typeface="Inter"/>
-                <a:ea typeface="Inter"/>
-                <a:cs typeface="Inter"/>
-              </a:rPr>
-              <a:t>It’s not enough to say what is needed; we have to think </a:t>
-            </a:r>
-            <a:r>
-              <a:rPr lang="en-US" sz="1300" i="1" dirty="0">
-                <a:solidFill>
-                  <a:srgbClr val="33424D"/>
-                </a:solidFill>
-                <a:latin typeface="Inter"/>
-                <a:ea typeface="Inter"/>
-                <a:cs typeface="Inter"/>
-              </a:rPr>
-              <a:t>how </a:t>
-            </a:r>
-            <a:r>
-              <a:rPr lang="en-US" sz="1300" dirty="0">
-                <a:solidFill>
-                  <a:srgbClr val="33424D"/>
-                </a:solidFill>
-                <a:latin typeface="Inter"/>
-                <a:ea typeface="Inter"/>
-                <a:cs typeface="Inter"/>
-              </a:rPr>
-              <a:t>to do those things in practice.</a:t>
-            </a:r>
-            <a:endParaRPr lang="en-US" sz="1300" dirty="0">
-              <a:solidFill>
-                <a:srgbClr val="6B7C88"/>
-              </a:solidFill>
-              <a:latin typeface="Inter"/>
-              <a:ea typeface="Inter"/>
-              <a:cs typeface="Inter"/>
-            </a:endParaRPr>
+              <a:t>(Initiative draft)</a:t>
+            </a:r>
           </a:p>
         </p:txBody>
       </p:sp>
@@ -5123,6 +5088,1941 @@
 </file>
 
 <file path=ppt/slides/slide7.xml><?xml version="1.0" encoding="utf-8"?>
+<p:sld xmlns:a="http://schemas.openxmlformats.org/drawingml/2006/main" xmlns:r="http://schemas.openxmlformats.org/officeDocument/2006/relationships" xmlns:p="http://schemas.openxmlformats.org/presentationml/2006/main">
+  <p:cSld name="Slide 6">
+    <p:bg>
+      <p:bgPr>
+        <a:solidFill>
+          <a:srgbClr val="F3F8F7"/>
+        </a:solidFill>
+        <a:effectLst/>
+      </p:bgPr>
+    </p:bg>
+    <p:spTree>
+      <p:nvGrpSpPr>
+        <p:cNvPr id="1" name=""/>
+        <p:cNvGrpSpPr/>
+        <p:nvPr/>
+      </p:nvGrpSpPr>
+      <p:grpSpPr>
+        <a:xfrm>
+          <a:off x="0" y="0"/>
+          <a:ext cx="0" cy="0"/>
+          <a:chOff x="0" y="0"/>
+          <a:chExt cx="0" cy="0"/>
+        </a:xfrm>
+      </p:grpSpPr>
+      <p:sp>
+        <p:nvSpPr>
+          <p:cNvPr id="2" name="Shape 0"/>
+          <p:cNvSpPr/>
+          <p:nvPr/>
+        </p:nvSpPr>
+        <p:spPr>
+          <a:xfrm>
+            <a:off x="0" y="0"/>
+            <a:ext cx="4063898" cy="146304"/>
+          </a:xfrm>
+          <a:prstGeom prst="rect">
+            <a:avLst/>
+          </a:prstGeom>
+          <a:solidFill>
+            <a:srgbClr val="0F9E8E"/>
+          </a:solidFill>
+          <a:ln/>
+        </p:spPr>
+        <p:txBody>
+          <a:bodyPr/>
+          <a:lstStyle/>
+          <a:p>
+            <a:endParaRPr lang="LID4096"/>
+          </a:p>
+        </p:txBody>
+      </p:sp>
+      <p:sp>
+        <p:nvSpPr>
+          <p:cNvPr id="3" name="Shape 1"/>
+          <p:cNvSpPr/>
+          <p:nvPr/>
+        </p:nvSpPr>
+        <p:spPr>
+          <a:xfrm>
+            <a:off x="4063898" y="0"/>
+            <a:ext cx="4063898" cy="146304"/>
+          </a:xfrm>
+          <a:prstGeom prst="rect">
+            <a:avLst/>
+          </a:prstGeom>
+          <a:solidFill>
+            <a:srgbClr val="2B3F9E"/>
+          </a:solidFill>
+          <a:ln/>
+        </p:spPr>
+        <p:txBody>
+          <a:bodyPr/>
+          <a:lstStyle/>
+          <a:p>
+            <a:endParaRPr lang="LID4096"/>
+          </a:p>
+        </p:txBody>
+      </p:sp>
+      <p:sp>
+        <p:nvSpPr>
+          <p:cNvPr id="4" name="Shape 2"/>
+          <p:cNvSpPr/>
+          <p:nvPr/>
+        </p:nvSpPr>
+        <p:spPr>
+          <a:xfrm>
+            <a:off x="8127797" y="0"/>
+            <a:ext cx="4063898" cy="146304"/>
+          </a:xfrm>
+          <a:prstGeom prst="rect">
+            <a:avLst/>
+          </a:prstGeom>
+          <a:solidFill>
+            <a:srgbClr val="F5A623"/>
+          </a:solidFill>
+          <a:ln/>
+        </p:spPr>
+        <p:txBody>
+          <a:bodyPr/>
+          <a:lstStyle/>
+          <a:p>
+            <a:endParaRPr lang="LID4096"/>
+          </a:p>
+        </p:txBody>
+      </p:sp>
+      <p:sp>
+        <p:nvSpPr>
+          <p:cNvPr id="10" name="Text 7"/>
+          <p:cNvSpPr/>
+          <p:nvPr/>
+        </p:nvSpPr>
+        <p:spPr>
+          <a:xfrm>
+            <a:off x="822960" y="960120"/>
+            <a:ext cx="10515600" cy="365760"/>
+          </a:xfrm>
+          <a:prstGeom prst="rect">
+            <a:avLst/>
+          </a:prstGeom>
+          <a:noFill/>
+          <a:ln/>
+        </p:spPr>
+        <p:txBody>
+          <a:bodyPr wrap="square" rtlCol="0" anchor="ctr"/>
+          <a:lstStyle/>
+          <a:p>
+            <a:pPr marL="0" indent="0" algn="l">
+              <a:buNone/>
+            </a:pPr>
+            <a:r>
+              <a:rPr lang="en-US" sz="1200" b="1" kern="0" spc="200" dirty="0">
+                <a:solidFill>
+                  <a:srgbClr val="0B6F63"/>
+                </a:solidFill>
+                <a:latin typeface="IBM Plex Mono" pitchFamily="34" charset="0"/>
+                <a:ea typeface="IBM Plex Mono" pitchFamily="34" charset="-122"/>
+                <a:cs typeface="IBM Plex Mono" pitchFamily="34" charset="-120"/>
+              </a:rPr>
+              <a:t>GOVERNANCE OF AI</a:t>
+            </a:r>
+            <a:endParaRPr lang="en-US" sz="1200" dirty="0"/>
+          </a:p>
+        </p:txBody>
+      </p:sp>
+      <p:sp>
+        <p:nvSpPr>
+          <p:cNvPr id="11" name="Text 8"/>
+          <p:cNvSpPr/>
+          <p:nvPr/>
+        </p:nvSpPr>
+        <p:spPr>
+          <a:xfrm>
+            <a:off x="786384" y="1463040"/>
+            <a:ext cx="10515600" cy="1371600"/>
+          </a:xfrm>
+          <a:prstGeom prst="rect">
+            <a:avLst/>
+          </a:prstGeom>
+          <a:noFill/>
+          <a:ln/>
+        </p:spPr>
+        <p:txBody>
+          <a:bodyPr wrap="square" rtlCol="0" anchor="t"/>
+          <a:lstStyle/>
+          <a:p>
+            <a:pPr marL="0" indent="0" algn="l">
+              <a:lnSpc>
+                <a:spcPct val="106000"/>
+              </a:lnSpc>
+              <a:buNone/>
+            </a:pPr>
+            <a:r>
+              <a:rPr lang="en-US" sz="3200" b="1" dirty="0">
+                <a:solidFill>
+                  <a:srgbClr val="14202B"/>
+                </a:solidFill>
+                <a:latin typeface="Sora" pitchFamily="34" charset="0"/>
+                <a:ea typeface="Sora" pitchFamily="34" charset="-122"/>
+                <a:cs typeface="Sora" pitchFamily="34" charset="-120"/>
+              </a:rPr>
+              <a:t>Governance must turn principles into structures, processes and enforcement.</a:t>
+            </a:r>
+            <a:endParaRPr lang="en-US" sz="3200" dirty="0"/>
+          </a:p>
+        </p:txBody>
+      </p:sp>
+      <p:sp>
+        <p:nvSpPr>
+          <p:cNvPr id="12" name="Text 9"/>
+          <p:cNvSpPr/>
+          <p:nvPr/>
+        </p:nvSpPr>
+        <p:spPr>
+          <a:xfrm>
+            <a:off x="822960" y="3108960"/>
+            <a:ext cx="10515600" cy="274320"/>
+          </a:xfrm>
+          <a:prstGeom prst="rect">
+            <a:avLst/>
+          </a:prstGeom>
+          <a:noFill/>
+          <a:ln/>
+        </p:spPr>
+        <p:txBody>
+          <a:bodyPr wrap="square" rtlCol="0" anchor="ctr"/>
+          <a:lstStyle/>
+          <a:p>
+            <a:pPr marL="0" indent="0" algn="l">
+              <a:buNone/>
+            </a:pPr>
+            <a:r>
+              <a:rPr lang="en-US" sz="1050" b="1" kern="0" spc="200" dirty="0">
+                <a:solidFill>
+                  <a:srgbClr val="0B6F63"/>
+                </a:solidFill>
+                <a:latin typeface="IBM Plex Mono" pitchFamily="34" charset="0"/>
+                <a:ea typeface="IBM Plex Mono" pitchFamily="34" charset="-122"/>
+                <a:cs typeface="IBM Plex Mono" pitchFamily="34" charset="-120"/>
+              </a:rPr>
+              <a:t>// WHERE TO FOCUS</a:t>
+            </a:r>
+            <a:endParaRPr lang="en-US" sz="1050" dirty="0"/>
+          </a:p>
+        </p:txBody>
+      </p:sp>
+      <p:sp>
+        <p:nvSpPr>
+          <p:cNvPr id="100" name="Shape 10"/>
+          <p:cNvSpPr/>
+          <p:nvPr/>
+        </p:nvSpPr>
+        <p:spPr>
+          <a:xfrm>
+            <a:off x="822960" y="3703320"/>
+            <a:ext cx="402336" cy="402336"/>
+          </a:xfrm>
+          <a:prstGeom prst="ellipse">
+            <a:avLst/>
+          </a:prstGeom>
+          <a:solidFill>
+            <a:srgbClr val="EAF6F3"/>
+          </a:solidFill>
+          <a:ln w="12700">
+            <a:solidFill>
+              <a:srgbClr val="BFE3DC"/>
+            </a:solidFill>
+            <a:prstDash val="solid"/>
+          </a:ln>
+        </p:spPr>
+        <p:txBody>
+          <a:bodyPr lIns="0" tIns="0" rIns="0" bIns="0" anchor="ctr"/>
+          <a:lstStyle/>
+          <a:p>
+            <a:pPr algn="ctr"/>
+            <a:r>
+              <a:rPr lang="en-US" sz="1300" b="1">
+                <a:solidFill>
+                  <a:srgbClr val="0B6F63"/>
+                </a:solidFill>
+                <a:latin typeface="IBM Plex Mono"/>
+              </a:rPr>
+              <a:t>1</a:t>
+            </a:r>
+          </a:p>
+        </p:txBody>
+      </p:sp>
+      <p:sp>
+        <p:nvSpPr>
+          <p:cNvPr id="101" name="Text 11"/>
+          <p:cNvSpPr/>
+          <p:nvPr/>
+        </p:nvSpPr>
+        <p:spPr>
+          <a:xfrm>
+            <a:off x="1353312" y="3657600"/>
+            <a:ext cx="4700000" cy="1143000"/>
+          </a:xfrm>
+          <a:prstGeom prst="rect">
+            <a:avLst/>
+          </a:prstGeom>
+          <a:noFill/>
+          <a:ln/>
+        </p:spPr>
+        <p:txBody>
+          <a:bodyPr wrap="square" rtlCol="0" anchor="t"/>
+          <a:lstStyle/>
+          <a:p>
+            <a:pPr marL="0" indent="0" algn="l">
+              <a:lnSpc>
+                <a:spcPct val="100000"/>
+              </a:lnSpc>
+              <a:buNone/>
+            </a:pPr>
+            <a:r>
+              <a:rPr lang="en-US" sz="1300" b="1" dirty="0">
+                <a:solidFill>
+                  <a:srgbClr val="0B6F63"/>
+                </a:solidFill>
+                <a:latin typeface="Inter"/>
+                <a:ea typeface="Inter"/>
+                <a:cs typeface="Inter"/>
+              </a:rPr>
+              <a:t>Answer how, not just what. </a:t>
+            </a:r>
+            <a:r>
+              <a:rPr lang="en-US" sz="1300" dirty="0">
+                <a:solidFill>
+                  <a:srgbClr val="33424D"/>
+                </a:solidFill>
+                <a:latin typeface="Inter"/>
+                <a:ea typeface="Inter"/>
+                <a:cs typeface="Inter"/>
+              </a:rPr>
+              <a:t>Ethical guidelines say what, not how, and can lose to commercial interests. Define structures, processes and relational mechanisms, with enforcement. </a:t>
+            </a:r>
+            <a:r>
+              <a:rPr lang="en-US" sz="1100" dirty="0">
+                <a:solidFill>
+                  <a:srgbClr val="6B7C88"/>
+                </a:solidFill>
+                <a:latin typeface="Inter"/>
+                <a:ea typeface="Inter"/>
+                <a:cs typeface="Inter"/>
+              </a:rPr>
+              <a:t>(Mittelstadt, 2019; Mäntymäki et al., 2022)</a:t>
+            </a:r>
+          </a:p>
+        </p:txBody>
+      </p:sp>
+      <p:sp>
+        <p:nvSpPr>
+          <p:cNvPr id="102" name="Shape 10"/>
+          <p:cNvSpPr/>
+          <p:nvPr/>
+        </p:nvSpPr>
+        <p:spPr>
+          <a:xfrm>
+            <a:off x="6217920" y="3703320"/>
+            <a:ext cx="402336" cy="402336"/>
+          </a:xfrm>
+          <a:prstGeom prst="ellipse">
+            <a:avLst/>
+          </a:prstGeom>
+          <a:solidFill>
+            <a:srgbClr val="EAF6F3"/>
+          </a:solidFill>
+          <a:ln w="12700">
+            <a:solidFill>
+              <a:srgbClr val="BFE3DC"/>
+            </a:solidFill>
+            <a:prstDash val="solid"/>
+          </a:ln>
+        </p:spPr>
+        <p:txBody>
+          <a:bodyPr lIns="0" tIns="0" rIns="0" bIns="0" anchor="ctr"/>
+          <a:lstStyle/>
+          <a:p>
+            <a:pPr algn="ctr"/>
+            <a:r>
+              <a:rPr lang="en-US" sz="1300" b="1">
+                <a:solidFill>
+                  <a:srgbClr val="0B6F63"/>
+                </a:solidFill>
+                <a:latin typeface="IBM Plex Mono"/>
+              </a:rPr>
+              <a:t>2</a:t>
+            </a:r>
+          </a:p>
+        </p:txBody>
+      </p:sp>
+      <p:sp>
+        <p:nvSpPr>
+          <p:cNvPr id="103" name="Text 11"/>
+          <p:cNvSpPr/>
+          <p:nvPr/>
+        </p:nvSpPr>
+        <p:spPr>
+          <a:xfrm>
+            <a:off x="6748272" y="3657600"/>
+            <a:ext cx="4700000" cy="1143000"/>
+          </a:xfrm>
+          <a:prstGeom prst="rect">
+            <a:avLst/>
+          </a:prstGeom>
+          <a:noFill/>
+          <a:ln/>
+        </p:spPr>
+        <p:txBody>
+          <a:bodyPr wrap="square" rtlCol="0" anchor="t"/>
+          <a:lstStyle/>
+          <a:p>
+            <a:pPr marL="0" indent="0" algn="l">
+              <a:lnSpc>
+                <a:spcPct val="100000"/>
+              </a:lnSpc>
+              <a:buNone/>
+            </a:pPr>
+            <a:r>
+              <a:rPr lang="en-US" sz="1300" b="1" dirty="0">
+                <a:solidFill>
+                  <a:srgbClr val="0B6F63"/>
+                </a:solidFill>
+                <a:latin typeface="Inter"/>
+                <a:ea typeface="Inter"/>
+                <a:cs typeface="Inter"/>
+              </a:rPr>
+              <a:t>Cover who, what, when and how. </a:t>
+            </a:r>
+            <a:r>
+              <a:rPr lang="en-US" sz="1300" dirty="0">
+                <a:solidFill>
+                  <a:srgbClr val="33424D"/>
+                </a:solidFill>
+                <a:latin typeface="Inter"/>
+                <a:ea typeface="Inter"/>
+                <a:cs typeface="Inter"/>
+              </a:rPr>
+              <a:t>Define who governs, what is governed, when across the lifecycle, and how through policies, tools and models. Think system-level, not just algorithm ethics. </a:t>
+            </a:r>
+            <a:r>
+              <a:rPr lang="en-US" sz="1100" dirty="0">
+                <a:solidFill>
+                  <a:srgbClr val="6B7C88"/>
+                </a:solidFill>
+                <a:latin typeface="Inter"/>
+                <a:ea typeface="Inter"/>
+                <a:cs typeface="Inter"/>
+              </a:rPr>
+              <a:t>(Batool et al., 2025; Lu et al., 2022)</a:t>
+            </a:r>
+          </a:p>
+        </p:txBody>
+      </p:sp>
+      <p:sp>
+        <p:nvSpPr>
+          <p:cNvPr id="104" name="Shape 10"/>
+          <p:cNvSpPr/>
+          <p:nvPr/>
+        </p:nvSpPr>
+        <p:spPr>
+          <a:xfrm>
+            <a:off x="822960" y="4937760"/>
+            <a:ext cx="402336" cy="402336"/>
+          </a:xfrm>
+          <a:prstGeom prst="ellipse">
+            <a:avLst/>
+          </a:prstGeom>
+          <a:solidFill>
+            <a:srgbClr val="EAF6F3"/>
+          </a:solidFill>
+          <a:ln w="12700">
+            <a:solidFill>
+              <a:srgbClr val="BFE3DC"/>
+            </a:solidFill>
+            <a:prstDash val="solid"/>
+          </a:ln>
+        </p:spPr>
+        <p:txBody>
+          <a:bodyPr lIns="0" tIns="0" rIns="0" bIns="0" anchor="ctr"/>
+          <a:lstStyle/>
+          <a:p>
+            <a:pPr algn="ctr"/>
+            <a:r>
+              <a:rPr lang="en-US" sz="1300" b="1">
+                <a:solidFill>
+                  <a:srgbClr val="0B6F63"/>
+                </a:solidFill>
+                <a:latin typeface="IBM Plex Mono"/>
+              </a:rPr>
+              <a:t>3</a:t>
+            </a:r>
+          </a:p>
+        </p:txBody>
+      </p:sp>
+      <p:sp>
+        <p:nvSpPr>
+          <p:cNvPr id="105" name="Text 11"/>
+          <p:cNvSpPr/>
+          <p:nvPr/>
+        </p:nvSpPr>
+        <p:spPr>
+          <a:xfrm>
+            <a:off x="1353312" y="4892040"/>
+            <a:ext cx="4700000" cy="1143000"/>
+          </a:xfrm>
+          <a:prstGeom prst="rect">
+            <a:avLst/>
+          </a:prstGeom>
+          <a:noFill/>
+          <a:ln/>
+        </p:spPr>
+        <p:txBody>
+          <a:bodyPr wrap="square" rtlCol="0" anchor="t"/>
+          <a:lstStyle/>
+          <a:p>
+            <a:pPr marL="0" indent="0" algn="l">
+              <a:lnSpc>
+                <a:spcPct val="100000"/>
+              </a:lnSpc>
+              <a:buNone/>
+            </a:pPr>
+            <a:r>
+              <a:rPr lang="en-US" sz="1300" b="1" dirty="0">
+                <a:solidFill>
+                  <a:srgbClr val="0B6F63"/>
+                </a:solidFill>
+                <a:latin typeface="Inter"/>
+                <a:ea typeface="Inter"/>
+                <a:cs typeface="Inter"/>
+              </a:rPr>
+              <a:t>Go beyond fairness and privacy. </a:t>
+            </a:r>
+            <a:r>
+              <a:rPr lang="en-US" sz="1300" dirty="0">
+                <a:solidFill>
+                  <a:srgbClr val="33424D"/>
+                </a:solidFill>
+                <a:latin typeface="Inter"/>
+                <a:ea typeface="Inter"/>
+                <a:cs typeface="Inter"/>
+              </a:rPr>
+              <a:t>Most solutions address only one or two principles. Build in the human-centered ones: control, autonomy, wellbeing and creativity. </a:t>
+            </a:r>
+            <a:r>
+              <a:rPr lang="en-US" sz="1100" dirty="0">
+                <a:solidFill>
+                  <a:srgbClr val="6B7C88"/>
+                </a:solidFill>
+                <a:latin typeface="Inter"/>
+                <a:ea typeface="Inter"/>
+                <a:cs typeface="Inter"/>
+              </a:rPr>
+              <a:t>(Batool et al., 2025; Russo et al., 2024)</a:t>
+            </a:r>
+          </a:p>
+        </p:txBody>
+      </p:sp>
+      <p:sp>
+        <p:nvSpPr>
+          <p:cNvPr id="106" name="Shape 10"/>
+          <p:cNvSpPr/>
+          <p:nvPr/>
+        </p:nvSpPr>
+        <p:spPr>
+          <a:xfrm>
+            <a:off x="6217920" y="4937760"/>
+            <a:ext cx="402336" cy="402336"/>
+          </a:xfrm>
+          <a:prstGeom prst="ellipse">
+            <a:avLst/>
+          </a:prstGeom>
+          <a:solidFill>
+            <a:srgbClr val="EAF6F3"/>
+          </a:solidFill>
+          <a:ln w="12700">
+            <a:solidFill>
+              <a:srgbClr val="BFE3DC"/>
+            </a:solidFill>
+            <a:prstDash val="solid"/>
+          </a:ln>
+        </p:spPr>
+        <p:txBody>
+          <a:bodyPr lIns="0" tIns="0" rIns="0" bIns="0" anchor="ctr"/>
+          <a:lstStyle/>
+          <a:p>
+            <a:pPr algn="ctr"/>
+            <a:r>
+              <a:rPr lang="en-US" sz="1300" b="1">
+                <a:solidFill>
+                  <a:srgbClr val="0B6F63"/>
+                </a:solidFill>
+                <a:latin typeface="IBM Plex Mono"/>
+              </a:rPr>
+              <a:t>4</a:t>
+            </a:r>
+          </a:p>
+        </p:txBody>
+      </p:sp>
+      <p:sp>
+        <p:nvSpPr>
+          <p:cNvPr id="107" name="Text 11"/>
+          <p:cNvSpPr/>
+          <p:nvPr/>
+        </p:nvSpPr>
+        <p:spPr>
+          <a:xfrm>
+            <a:off x="6748272" y="4892040"/>
+            <a:ext cx="4700000" cy="1143000"/>
+          </a:xfrm>
+          <a:prstGeom prst="rect">
+            <a:avLst/>
+          </a:prstGeom>
+          <a:noFill/>
+          <a:ln/>
+        </p:spPr>
+        <p:txBody>
+          <a:bodyPr wrap="square" rtlCol="0" anchor="t"/>
+          <a:lstStyle/>
+          <a:p>
+            <a:pPr marL="0" indent="0" algn="l">
+              <a:lnSpc>
+                <a:spcPct val="100000"/>
+              </a:lnSpc>
+              <a:buNone/>
+            </a:pPr>
+            <a:r>
+              <a:rPr lang="en-US" sz="1300" b="1" dirty="0">
+                <a:solidFill>
+                  <a:srgbClr val="0B6F63"/>
+                </a:solidFill>
+                <a:latin typeface="Inter"/>
+                <a:ea typeface="Inter"/>
+                <a:cs typeface="Inter"/>
+              </a:rPr>
+              <a:t>Make it actionable. </a:t>
+            </a:r>
+            <a:r>
+              <a:rPr lang="en-US" sz="1300" dirty="0">
+                <a:solidFill>
+                  <a:srgbClr val="33424D"/>
+                </a:solidFill>
+                <a:latin typeface="Inter"/>
+                <a:ea typeface="Inter"/>
+                <a:cs typeface="Inter"/>
+              </a:rPr>
+              <a:t>Use concrete patterns, fit them to culture, leadership and up-skilling, and test with Action Research in real organizations. </a:t>
+            </a:r>
+            <a:r>
+              <a:rPr lang="en-US" sz="1100" dirty="0">
+                <a:solidFill>
+                  <a:srgbClr val="6B7C88"/>
+                </a:solidFill>
+                <a:latin typeface="Inter"/>
+                <a:ea typeface="Inter"/>
+                <a:cs typeface="Inter"/>
+              </a:rPr>
+              <a:t>(Lu et al., 2022; Tavantzis et al., 2027)</a:t>
+            </a:r>
+          </a:p>
+        </p:txBody>
+      </p:sp>
+      <p:sp>
+        <p:nvSpPr>
+          <p:cNvPr id="25" name="Text 18"/>
+          <p:cNvSpPr/>
+          <p:nvPr/>
+        </p:nvSpPr>
+        <p:spPr>
+          <a:xfrm>
+            <a:off x="822960" y="6419088"/>
+            <a:ext cx="10515600" cy="274320"/>
+          </a:xfrm>
+          <a:prstGeom prst="rect">
+            <a:avLst/>
+          </a:prstGeom>
+          <a:noFill/>
+          <a:ln/>
+        </p:spPr>
+        <p:txBody>
+          <a:bodyPr wrap="square" rtlCol="0" anchor="ctr"/>
+          <a:lstStyle/>
+          <a:p>
+            <a:pPr marL="0" indent="0" algn="l">
+              <a:buNone/>
+            </a:pPr>
+            <a:r>
+              <a:rPr lang="en-US" sz="900" dirty="0">
+                <a:solidFill>
+                  <a:srgbClr val="5B6B77"/>
+                </a:solidFill>
+                <a:latin typeface="Inter" pitchFamily="34" charset="0"/>
+                <a:ea typeface="Inter" pitchFamily="34" charset="-122"/>
+                <a:cs typeface="Inter" pitchFamily="34" charset="-120"/>
+              </a:rPr>
+              <a:t>Reflexive AI Research Initiative · Lucid Institute for Organizational Science</a:t>
+            </a:r>
+            <a:endParaRPr lang="en-US" sz="900" dirty="0"/>
+          </a:p>
+        </p:txBody>
+      </p:sp>
+    </p:spTree>
+  </p:cSld>
+  <p:clrMapOvr>
+    <a:masterClrMapping/>
+  </p:clrMapOvr>
+</p:sld>
+</file>
+
+<file path=ppt/slides/slide8.xml><?xml version="1.0" encoding="utf-8"?>
+<p:sld xmlns:a="http://schemas.openxmlformats.org/drawingml/2006/main" xmlns:r="http://schemas.openxmlformats.org/officeDocument/2006/relationships" xmlns:p="http://schemas.openxmlformats.org/presentationml/2006/main">
+  <p:cSld name="Slide 6">
+    <p:bg>
+      <p:bgPr>
+        <a:solidFill>
+          <a:srgbClr val="F3F8F7"/>
+        </a:solidFill>
+        <a:effectLst/>
+      </p:bgPr>
+    </p:bg>
+    <p:spTree>
+      <p:nvGrpSpPr>
+        <p:cNvPr id="1" name=""/>
+        <p:cNvGrpSpPr/>
+        <p:nvPr/>
+      </p:nvGrpSpPr>
+      <p:grpSpPr>
+        <a:xfrm>
+          <a:off x="0" y="0"/>
+          <a:ext cx="0" cy="0"/>
+          <a:chOff x="0" y="0"/>
+          <a:chExt cx="0" cy="0"/>
+        </a:xfrm>
+      </p:grpSpPr>
+      <p:sp>
+        <p:nvSpPr>
+          <p:cNvPr id="2" name="Shape 0"/>
+          <p:cNvSpPr/>
+          <p:nvPr/>
+        </p:nvSpPr>
+        <p:spPr>
+          <a:xfrm>
+            <a:off x="0" y="0"/>
+            <a:ext cx="4063898" cy="146304"/>
+          </a:xfrm>
+          <a:prstGeom prst="rect">
+            <a:avLst/>
+          </a:prstGeom>
+          <a:solidFill>
+            <a:srgbClr val="0F9E8E"/>
+          </a:solidFill>
+          <a:ln/>
+        </p:spPr>
+        <p:txBody>
+          <a:bodyPr/>
+          <a:lstStyle/>
+          <a:p>
+            <a:endParaRPr lang="LID4096"/>
+          </a:p>
+        </p:txBody>
+      </p:sp>
+      <p:sp>
+        <p:nvSpPr>
+          <p:cNvPr id="3" name="Shape 1"/>
+          <p:cNvSpPr/>
+          <p:nvPr/>
+        </p:nvSpPr>
+        <p:spPr>
+          <a:xfrm>
+            <a:off x="4063898" y="0"/>
+            <a:ext cx="4063898" cy="146304"/>
+          </a:xfrm>
+          <a:prstGeom prst="rect">
+            <a:avLst/>
+          </a:prstGeom>
+          <a:solidFill>
+            <a:srgbClr val="2B3F9E"/>
+          </a:solidFill>
+          <a:ln/>
+        </p:spPr>
+        <p:txBody>
+          <a:bodyPr/>
+          <a:lstStyle/>
+          <a:p>
+            <a:endParaRPr lang="LID4096"/>
+          </a:p>
+        </p:txBody>
+      </p:sp>
+      <p:sp>
+        <p:nvSpPr>
+          <p:cNvPr id="4" name="Shape 2"/>
+          <p:cNvSpPr/>
+          <p:nvPr/>
+        </p:nvSpPr>
+        <p:spPr>
+          <a:xfrm>
+            <a:off x="8127797" y="0"/>
+            <a:ext cx="4063898" cy="146304"/>
+          </a:xfrm>
+          <a:prstGeom prst="rect">
+            <a:avLst/>
+          </a:prstGeom>
+          <a:solidFill>
+            <a:srgbClr val="F5A623"/>
+          </a:solidFill>
+          <a:ln/>
+        </p:spPr>
+        <p:txBody>
+          <a:bodyPr/>
+          <a:lstStyle/>
+          <a:p>
+            <a:endParaRPr lang="LID4096"/>
+          </a:p>
+        </p:txBody>
+      </p:sp>
+      <p:sp>
+        <p:nvSpPr>
+          <p:cNvPr id="10" name="Text 7"/>
+          <p:cNvSpPr/>
+          <p:nvPr/>
+        </p:nvSpPr>
+        <p:spPr>
+          <a:xfrm>
+            <a:off x="822960" y="960120"/>
+            <a:ext cx="10515600" cy="365760"/>
+          </a:xfrm>
+          <a:prstGeom prst="rect">
+            <a:avLst/>
+          </a:prstGeom>
+          <a:noFill/>
+          <a:ln/>
+        </p:spPr>
+        <p:txBody>
+          <a:bodyPr wrap="square" rtlCol="0" anchor="ctr"/>
+          <a:lstStyle/>
+          <a:p>
+            <a:pPr marL="0" indent="0" algn="l">
+              <a:buNone/>
+            </a:pPr>
+            <a:r>
+              <a:rPr lang="en-US" sz="1200" b="1" kern="0" spc="200" dirty="0">
+                <a:solidFill>
+                  <a:srgbClr val="0B6F63"/>
+                </a:solidFill>
+                <a:latin typeface="IBM Plex Mono" pitchFamily="34" charset="0"/>
+                <a:ea typeface="IBM Plex Mono" pitchFamily="34" charset="-122"/>
+                <a:cs typeface="IBM Plex Mono" pitchFamily="34" charset="-120"/>
+              </a:rPr>
+              <a:t>GOVERNANCE FRAMEWORK THEMES · BASED ON TAVANTZIS ET AL., 2027</a:t>
+            </a:r>
+            <a:endParaRPr lang="en-US" sz="1200" dirty="0"/>
+          </a:p>
+        </p:txBody>
+      </p:sp>
+      <p:sp>
+        <p:nvSpPr>
+          <p:cNvPr id="11" name="Text 8"/>
+          <p:cNvSpPr/>
+          <p:nvPr/>
+        </p:nvSpPr>
+        <p:spPr>
+          <a:xfrm>
+            <a:off x="786384" y="1463040"/>
+            <a:ext cx="10515600" cy="1371600"/>
+          </a:xfrm>
+          <a:prstGeom prst="rect">
+            <a:avLst/>
+          </a:prstGeom>
+          <a:noFill/>
+          <a:ln/>
+        </p:spPr>
+        <p:txBody>
+          <a:bodyPr wrap="square" rtlCol="0" anchor="t"/>
+          <a:lstStyle/>
+          <a:p>
+            <a:pPr marL="0" indent="0" algn="l">
+              <a:lnSpc>
+                <a:spcPct val="106000"/>
+              </a:lnSpc>
+              <a:buNone/>
+            </a:pPr>
+            <a:r>
+              <a:rPr lang="en-US" sz="3200" b="1" dirty="0">
+                <a:solidFill>
+                  <a:srgbClr val="14202B"/>
+                </a:solidFill>
+                <a:latin typeface="Sora" pitchFamily="34" charset="0"/>
+                <a:ea typeface="Sora" pitchFamily="34" charset="-122"/>
+                <a:cs typeface="Sora" pitchFamily="34" charset="-120"/>
+              </a:rPr>
+              <a:t>Twelve </a:t>
+            </a:r>
+            <a:r>
+              <a:rPr lang="en-US" sz="3200" b="1" u="sng" dirty="0">
+                <a:solidFill>
+                  <a:srgbClr val="14202B"/>
+                </a:solidFill>
+                <a:latin typeface="Sora" pitchFamily="34" charset="0"/>
+                <a:ea typeface="Sora" pitchFamily="34" charset="-122"/>
+                <a:cs typeface="Sora" pitchFamily="34" charset="-120"/>
+              </a:rPr>
+              <a:t>starting</a:t>
+            </a:r>
+            <a:r>
+              <a:rPr lang="en-US" sz="3200" b="1" dirty="0">
+                <a:solidFill>
+                  <a:srgbClr val="14202B"/>
+                </a:solidFill>
+                <a:latin typeface="Sora" pitchFamily="34" charset="0"/>
+                <a:ea typeface="Sora" pitchFamily="34" charset="-122"/>
+                <a:cs typeface="Sora" pitchFamily="34" charset="-120"/>
+              </a:rPr>
+              <a:t> themes for AI governance.</a:t>
+            </a:r>
+            <a:endParaRPr lang="en-US" sz="3200" dirty="0"/>
+          </a:p>
+        </p:txBody>
+      </p:sp>
+      <p:sp>
+        <p:nvSpPr>
+          <p:cNvPr id="200" name="Shape 200"/>
+          <p:cNvSpPr/>
+          <p:nvPr/>
+        </p:nvSpPr>
+        <p:spPr>
+          <a:xfrm>
+            <a:off x="822960" y="2377440"/>
+            <a:ext cx="3322320" cy="3794760"/>
+          </a:xfrm>
+          <a:prstGeom prst="roundRect">
+            <a:avLst>
+              <a:gd name="adj" fmla="val 4000"/>
+            </a:avLst>
+          </a:prstGeom>
+          <a:solidFill>
+            <a:srgbClr val="FFFFFF"/>
+          </a:solidFill>
+          <a:ln w="12700">
+            <a:solidFill>
+              <a:srgbClr val="DCE8E5"/>
+            </a:solidFill>
+          </a:ln>
+        </p:spPr>
+        <p:txBody>
+          <a:bodyPr wrap="square" lIns="0" tIns="0" rIns="0" bIns="0" anchor="t"/>
+          <a:lstStyle/>
+          <a:p>
+            <a:endParaRPr lang="en-US"/>
+          </a:p>
+        </p:txBody>
+      </p:sp>
+      <p:sp>
+        <p:nvSpPr>
+          <p:cNvPr id="201" name="Shape 201"/>
+          <p:cNvSpPr/>
+          <p:nvPr/>
+        </p:nvSpPr>
+        <p:spPr>
+          <a:xfrm>
+            <a:off x="1005840" y="2542032"/>
+            <a:ext cx="2956560" cy="320040"/>
+          </a:xfrm>
+          <a:prstGeom prst="roundRect">
+            <a:avLst>
+              <a:gd name="adj" fmla="val 50000"/>
+            </a:avLst>
+          </a:prstGeom>
+          <a:solidFill>
+            <a:srgbClr val="EAF6F3"/>
+          </a:solidFill>
+          <a:ln w="12700">
+            <a:solidFill>
+              <a:srgbClr val="BFE3DC"/>
+            </a:solidFill>
+          </a:ln>
+        </p:spPr>
+        <p:txBody>
+          <a:bodyPr wrap="square" lIns="0" tIns="0" rIns="0" bIns="0" anchor="ctr"/>
+          <a:lstStyle/>
+          <a:p>
+            <a:pPr marL="0" indent="0" algn="ctr">
+              <a:spcAft>
+                <a:spcPts val="0"/>
+              </a:spcAft>
+              <a:buNone/>
+            </a:pPr>
+            <a:r>
+              <a:rPr lang="en-US" sz="1000" b="1" spc="100" dirty="0">
+                <a:solidFill>
+                  <a:srgbClr val="0B6F63"/>
+                </a:solidFill>
+                <a:latin typeface="IBM Plex Mono"/>
+                <a:ea typeface="IBM Plex Mono"/>
+                <a:cs typeface="IBM Plex Mono"/>
+              </a:rPr>
+              <a:t>DIRECTION &amp; ACCOUNTABILITY</a:t>
+            </a:r>
+          </a:p>
+        </p:txBody>
+      </p:sp>
+      <p:sp>
+        <p:nvSpPr>
+          <p:cNvPr id="202" name="Shape 202"/>
+          <p:cNvSpPr/>
+          <p:nvPr/>
+        </p:nvSpPr>
+        <p:spPr>
+          <a:xfrm>
+            <a:off x="1051560" y="3017520"/>
+            <a:ext cx="2865120" cy="680000"/>
+          </a:xfrm>
+          <a:prstGeom prst="rect">
+            <a:avLst/>
+          </a:prstGeom>
+          <a:noFill/>
+          <a:ln>
+            <a:noFill/>
+          </a:ln>
+        </p:spPr>
+        <p:txBody>
+          <a:bodyPr wrap="square" lIns="0" tIns="0" rIns="0" bIns="0" anchor="t"/>
+          <a:lstStyle/>
+          <a:p>
+            <a:pPr marL="0" indent="0" algn="l">
+              <a:spcAft>
+                <a:spcPts val="200"/>
+              </a:spcAft>
+              <a:buNone/>
+            </a:pPr>
+            <a:r>
+              <a:rPr lang="en-US" sz="1200" b="1" dirty="0">
+                <a:solidFill>
+                  <a:srgbClr val="14202B"/>
+                </a:solidFill>
+                <a:latin typeface="Inter"/>
+                <a:ea typeface="Inter"/>
+                <a:cs typeface="Inter"/>
+              </a:rPr>
+              <a:t>AI Strategy Design</a:t>
+            </a:r>
+          </a:p>
+          <a:p>
+            <a:pPr marL="0" indent="0" algn="l">
+              <a:spcAft>
+                <a:spcPts val="0"/>
+              </a:spcAft>
+              <a:buNone/>
+            </a:pPr>
+            <a:r>
+              <a:rPr lang="en-US" sz="1050" dirty="0">
+                <a:solidFill>
+                  <a:srgbClr val="33424D"/>
+                </a:solidFill>
+                <a:latin typeface="Inter"/>
+                <a:ea typeface="Inter"/>
+                <a:cs typeface="Inter"/>
+              </a:rPr>
+              <a:t>Anchor AI goals in purpose and human-centered aims</a:t>
+            </a:r>
+          </a:p>
+        </p:txBody>
+      </p:sp>
+      <p:sp>
+        <p:nvSpPr>
+          <p:cNvPr id="203" name="Shape 203"/>
+          <p:cNvSpPr/>
+          <p:nvPr/>
+        </p:nvSpPr>
+        <p:spPr>
+          <a:xfrm>
+            <a:off x="1051560" y="3737520"/>
+            <a:ext cx="2865120" cy="680000"/>
+          </a:xfrm>
+          <a:prstGeom prst="rect">
+            <a:avLst/>
+          </a:prstGeom>
+          <a:noFill/>
+          <a:ln>
+            <a:noFill/>
+          </a:ln>
+        </p:spPr>
+        <p:txBody>
+          <a:bodyPr wrap="square" lIns="0" tIns="0" rIns="0" bIns="0" anchor="t"/>
+          <a:lstStyle/>
+          <a:p>
+            <a:pPr marL="0" indent="0" algn="l">
+              <a:spcAft>
+                <a:spcPts val="200"/>
+              </a:spcAft>
+              <a:buNone/>
+            </a:pPr>
+            <a:r>
+              <a:rPr lang="en-US" sz="1200" b="1" dirty="0">
+                <a:solidFill>
+                  <a:srgbClr val="14202B"/>
+                </a:solidFill>
+                <a:latin typeface="Inter"/>
+                <a:ea typeface="Inter"/>
+                <a:cs typeface="Inter"/>
+              </a:rPr>
+              <a:t>AI Strategy Evaluation</a:t>
+            </a:r>
+          </a:p>
+          <a:p>
+            <a:pPr marL="0" indent="0" algn="l">
+              <a:spcAft>
+                <a:spcPts val="0"/>
+              </a:spcAft>
+              <a:buNone/>
+            </a:pPr>
+            <a:r>
+              <a:rPr lang="en-US" sz="1050" dirty="0">
+                <a:solidFill>
+                  <a:srgbClr val="33424D"/>
+                </a:solidFill>
+                <a:latin typeface="Inter"/>
+                <a:ea typeface="Inter"/>
+                <a:cs typeface="Inter"/>
+              </a:rPr>
+              <a:t>Review outcomes and harms, not only productivity</a:t>
+            </a:r>
+          </a:p>
+        </p:txBody>
+      </p:sp>
+      <p:sp>
+        <p:nvSpPr>
+          <p:cNvPr id="204" name="Shape 204"/>
+          <p:cNvSpPr/>
+          <p:nvPr/>
+        </p:nvSpPr>
+        <p:spPr>
+          <a:xfrm>
+            <a:off x="1051560" y="4457520"/>
+            <a:ext cx="2865120" cy="680000"/>
+          </a:xfrm>
+          <a:prstGeom prst="rect">
+            <a:avLst/>
+          </a:prstGeom>
+          <a:noFill/>
+          <a:ln>
+            <a:noFill/>
+          </a:ln>
+        </p:spPr>
+        <p:txBody>
+          <a:bodyPr wrap="square" lIns="0" tIns="0" rIns="0" bIns="0" anchor="t"/>
+          <a:lstStyle/>
+          <a:p>
+            <a:pPr marL="0" indent="0" algn="l">
+              <a:spcAft>
+                <a:spcPts val="200"/>
+              </a:spcAft>
+              <a:buNone/>
+            </a:pPr>
+            <a:r>
+              <a:rPr lang="en-US" sz="1200" b="1" dirty="0">
+                <a:solidFill>
+                  <a:srgbClr val="14202B"/>
+                </a:solidFill>
+                <a:latin typeface="Inter"/>
+                <a:ea typeface="Inter"/>
+                <a:cs typeface="Inter"/>
+              </a:rPr>
+              <a:t>Leadership</a:t>
+            </a:r>
+          </a:p>
+          <a:p>
+            <a:pPr marL="0" indent="0" algn="l">
+              <a:spcAft>
+                <a:spcPts val="0"/>
+              </a:spcAft>
+              <a:buNone/>
+            </a:pPr>
+            <a:r>
+              <a:rPr lang="en-US" sz="1050" dirty="0">
+                <a:solidFill>
+                  <a:srgbClr val="33424D"/>
+                </a:solidFill>
+                <a:latin typeface="Inter"/>
+                <a:ea typeface="Inter"/>
+                <a:cs typeface="Inter"/>
+              </a:rPr>
+              <a:t>Set ownership and accountability for AI decisions</a:t>
+            </a:r>
+          </a:p>
+        </p:txBody>
+      </p:sp>
+      <p:sp>
+        <p:nvSpPr>
+          <p:cNvPr id="205" name="Shape 205"/>
+          <p:cNvSpPr/>
+          <p:nvPr/>
+        </p:nvSpPr>
+        <p:spPr>
+          <a:xfrm>
+            <a:off x="1051560" y="5177520"/>
+            <a:ext cx="2865120" cy="680000"/>
+          </a:xfrm>
+          <a:prstGeom prst="rect">
+            <a:avLst/>
+          </a:prstGeom>
+          <a:noFill/>
+          <a:ln>
+            <a:noFill/>
+          </a:ln>
+        </p:spPr>
+        <p:txBody>
+          <a:bodyPr wrap="square" lIns="0" tIns="0" rIns="0" bIns="0" anchor="t"/>
+          <a:lstStyle/>
+          <a:p>
+            <a:pPr marL="0" indent="0" algn="l">
+              <a:spcAft>
+                <a:spcPts val="200"/>
+              </a:spcAft>
+              <a:buNone/>
+            </a:pPr>
+            <a:r>
+              <a:rPr lang="en-US" sz="1200" b="1" dirty="0">
+                <a:solidFill>
+                  <a:srgbClr val="14202B"/>
+                </a:solidFill>
+                <a:latin typeface="Inter"/>
+                <a:ea typeface="Inter"/>
+                <a:cs typeface="Inter"/>
+              </a:rPr>
+              <a:t>Governance &amp; Ethics</a:t>
+            </a:r>
+          </a:p>
+          <a:p>
+            <a:pPr marL="0" indent="0" algn="l">
+              <a:spcAft>
+                <a:spcPts val="0"/>
+              </a:spcAft>
+              <a:buNone/>
+            </a:pPr>
+            <a:r>
+              <a:rPr lang="en-US" sz="1050" dirty="0">
+                <a:solidFill>
+                  <a:srgbClr val="33424D"/>
+                </a:solidFill>
+                <a:latin typeface="Inter"/>
+                <a:ea typeface="Inter"/>
+                <a:cs typeface="Inter"/>
+              </a:rPr>
+              <a:t>Turn principles into rules, roles and enforcement</a:t>
+            </a:r>
+          </a:p>
+        </p:txBody>
+      </p:sp>
+      <p:sp>
+        <p:nvSpPr>
+          <p:cNvPr id="206" name="Shape 206"/>
+          <p:cNvSpPr/>
+          <p:nvPr/>
+        </p:nvSpPr>
+        <p:spPr>
+          <a:xfrm>
+            <a:off x="4419600" y="2377440"/>
+            <a:ext cx="3322320" cy="3794760"/>
+          </a:xfrm>
+          <a:prstGeom prst="roundRect">
+            <a:avLst>
+              <a:gd name="adj" fmla="val 4000"/>
+            </a:avLst>
+          </a:prstGeom>
+          <a:solidFill>
+            <a:srgbClr val="FFFFFF"/>
+          </a:solidFill>
+          <a:ln w="12700">
+            <a:solidFill>
+              <a:srgbClr val="DCE8E5"/>
+            </a:solidFill>
+          </a:ln>
+        </p:spPr>
+        <p:txBody>
+          <a:bodyPr wrap="square" lIns="0" tIns="0" rIns="0" bIns="0" anchor="t"/>
+          <a:lstStyle/>
+          <a:p>
+            <a:endParaRPr lang="en-US"/>
+          </a:p>
+        </p:txBody>
+      </p:sp>
+      <p:sp>
+        <p:nvSpPr>
+          <p:cNvPr id="207" name="Shape 207"/>
+          <p:cNvSpPr/>
+          <p:nvPr/>
+        </p:nvSpPr>
+        <p:spPr>
+          <a:xfrm>
+            <a:off x="4602480" y="2542032"/>
+            <a:ext cx="2956560" cy="320040"/>
+          </a:xfrm>
+          <a:prstGeom prst="roundRect">
+            <a:avLst>
+              <a:gd name="adj" fmla="val 50000"/>
+            </a:avLst>
+          </a:prstGeom>
+          <a:solidFill>
+            <a:srgbClr val="E8EBF8"/>
+          </a:solidFill>
+          <a:ln w="12700">
+            <a:solidFill>
+              <a:srgbClr val="C6CDEE"/>
+            </a:solidFill>
+          </a:ln>
+        </p:spPr>
+        <p:txBody>
+          <a:bodyPr wrap="square" lIns="0" tIns="0" rIns="0" bIns="0" anchor="ctr"/>
+          <a:lstStyle/>
+          <a:p>
+            <a:pPr marL="0" indent="0" algn="ctr">
+              <a:spcAft>
+                <a:spcPts val="0"/>
+              </a:spcAft>
+              <a:buNone/>
+            </a:pPr>
+            <a:r>
+              <a:rPr lang="en-US" sz="1000" b="1" spc="100" dirty="0">
+                <a:solidFill>
+                  <a:srgbClr val="2B3F9E"/>
+                </a:solidFill>
+                <a:latin typeface="IBM Plex Mono"/>
+                <a:ea typeface="IBM Plex Mono"/>
+                <a:cs typeface="IBM Plex Mono"/>
+              </a:rPr>
+              <a:t>PEOPLE &amp; ORGANIZATION</a:t>
+            </a:r>
+          </a:p>
+        </p:txBody>
+      </p:sp>
+      <p:sp>
+        <p:nvSpPr>
+          <p:cNvPr id="208" name="Shape 208"/>
+          <p:cNvSpPr/>
+          <p:nvPr/>
+        </p:nvSpPr>
+        <p:spPr>
+          <a:xfrm>
+            <a:off x="4648200" y="3017520"/>
+            <a:ext cx="2865120" cy="680000"/>
+          </a:xfrm>
+          <a:prstGeom prst="rect">
+            <a:avLst/>
+          </a:prstGeom>
+          <a:noFill/>
+          <a:ln>
+            <a:noFill/>
+          </a:ln>
+        </p:spPr>
+        <p:txBody>
+          <a:bodyPr wrap="square" lIns="0" tIns="0" rIns="0" bIns="0" anchor="t"/>
+          <a:lstStyle/>
+          <a:p>
+            <a:pPr marL="0" indent="0" algn="l">
+              <a:spcAft>
+                <a:spcPts val="200"/>
+              </a:spcAft>
+              <a:buNone/>
+            </a:pPr>
+            <a:r>
+              <a:rPr lang="en-US" sz="1200" b="1" dirty="0">
+                <a:solidFill>
+                  <a:srgbClr val="14202B"/>
+                </a:solidFill>
+                <a:latin typeface="Inter"/>
+                <a:ea typeface="Inter"/>
+                <a:cs typeface="Inter"/>
+              </a:rPr>
+              <a:t>Collaboration</a:t>
+            </a:r>
+          </a:p>
+          <a:p>
+            <a:pPr marL="0" indent="0" algn="l">
+              <a:spcAft>
+                <a:spcPts val="0"/>
+              </a:spcAft>
+              <a:buNone/>
+            </a:pPr>
+            <a:r>
+              <a:rPr lang="en-US" sz="1050" dirty="0">
+                <a:solidFill>
+                  <a:srgbClr val="33424D"/>
+                </a:solidFill>
+                <a:latin typeface="Inter"/>
+                <a:ea typeface="Inter"/>
+                <a:cs typeface="Inter"/>
+              </a:rPr>
+              <a:t>Involve employees, IT, HR, legal and risk in decisions</a:t>
+            </a:r>
+          </a:p>
+        </p:txBody>
+      </p:sp>
+      <p:sp>
+        <p:nvSpPr>
+          <p:cNvPr id="209" name="Shape 209"/>
+          <p:cNvSpPr/>
+          <p:nvPr/>
+        </p:nvSpPr>
+        <p:spPr>
+          <a:xfrm>
+            <a:off x="4648200" y="3737520"/>
+            <a:ext cx="2865120" cy="680000"/>
+          </a:xfrm>
+          <a:prstGeom prst="rect">
+            <a:avLst/>
+          </a:prstGeom>
+          <a:noFill/>
+          <a:ln>
+            <a:noFill/>
+          </a:ln>
+        </p:spPr>
+        <p:txBody>
+          <a:bodyPr wrap="square" lIns="0" tIns="0" rIns="0" bIns="0" anchor="t"/>
+          <a:lstStyle/>
+          <a:p>
+            <a:pPr marL="0" indent="0" algn="l">
+              <a:spcAft>
+                <a:spcPts val="200"/>
+              </a:spcAft>
+              <a:buNone/>
+            </a:pPr>
+            <a:r>
+              <a:rPr lang="en-US" sz="1200" b="1" dirty="0">
+                <a:solidFill>
+                  <a:srgbClr val="14202B"/>
+                </a:solidFill>
+                <a:latin typeface="Inter"/>
+                <a:ea typeface="Inter"/>
+                <a:cs typeface="Inter"/>
+              </a:rPr>
+              <a:t>Communication</a:t>
+            </a:r>
+          </a:p>
+          <a:p>
+            <a:pPr marL="0" indent="0" algn="l">
+              <a:spcAft>
+                <a:spcPts val="0"/>
+              </a:spcAft>
+              <a:buNone/>
+            </a:pPr>
+            <a:r>
+              <a:rPr lang="en-US" sz="1050" dirty="0">
+                <a:solidFill>
+                  <a:srgbClr val="33424D"/>
+                </a:solidFill>
+                <a:latin typeface="Inter"/>
+                <a:ea typeface="Inter"/>
+                <a:cs typeface="Inter"/>
+              </a:rPr>
+              <a:t>Keep AI use and decision logic transparent</a:t>
+            </a:r>
+          </a:p>
+        </p:txBody>
+      </p:sp>
+      <p:sp>
+        <p:nvSpPr>
+          <p:cNvPr id="210" name="Shape 210"/>
+          <p:cNvSpPr/>
+          <p:nvPr/>
+        </p:nvSpPr>
+        <p:spPr>
+          <a:xfrm>
+            <a:off x="4648200" y="4457520"/>
+            <a:ext cx="2865120" cy="680000"/>
+          </a:xfrm>
+          <a:prstGeom prst="rect">
+            <a:avLst/>
+          </a:prstGeom>
+          <a:noFill/>
+          <a:ln>
+            <a:noFill/>
+          </a:ln>
+        </p:spPr>
+        <p:txBody>
+          <a:bodyPr wrap="square" lIns="0" tIns="0" rIns="0" bIns="0" anchor="t"/>
+          <a:lstStyle/>
+          <a:p>
+            <a:pPr marL="0" indent="0" algn="l">
+              <a:spcAft>
+                <a:spcPts val="200"/>
+              </a:spcAft>
+              <a:buNone/>
+            </a:pPr>
+            <a:r>
+              <a:rPr lang="en-US" sz="1200" b="1" dirty="0">
+                <a:solidFill>
+                  <a:srgbClr val="14202B"/>
+                </a:solidFill>
+                <a:latin typeface="Inter"/>
+                <a:ea typeface="Inter"/>
+                <a:cs typeface="Inter"/>
+              </a:rPr>
+              <a:t>Organizational Culture</a:t>
+            </a:r>
+          </a:p>
+          <a:p>
+            <a:pPr marL="0" indent="0" algn="l">
+              <a:spcAft>
+                <a:spcPts val="0"/>
+              </a:spcAft>
+              <a:buNone/>
+            </a:pPr>
+            <a:r>
+              <a:rPr lang="en-US" sz="1050" dirty="0">
+                <a:solidFill>
+                  <a:srgbClr val="33424D"/>
+                </a:solidFill>
+                <a:latin typeface="Inter"/>
+                <a:ea typeface="Inter"/>
+                <a:cs typeface="Inter"/>
+              </a:rPr>
+              <a:t>Make it safe to question or reject AI output</a:t>
+            </a:r>
+          </a:p>
+        </p:txBody>
+      </p:sp>
+      <p:sp>
+        <p:nvSpPr>
+          <p:cNvPr id="211" name="Shape 211"/>
+          <p:cNvSpPr/>
+          <p:nvPr/>
+        </p:nvSpPr>
+        <p:spPr>
+          <a:xfrm>
+            <a:off x="4648200" y="5177520"/>
+            <a:ext cx="2865120" cy="680000"/>
+          </a:xfrm>
+          <a:prstGeom prst="rect">
+            <a:avLst/>
+          </a:prstGeom>
+          <a:noFill/>
+          <a:ln>
+            <a:noFill/>
+          </a:ln>
+        </p:spPr>
+        <p:txBody>
+          <a:bodyPr wrap="square" lIns="0" tIns="0" rIns="0" bIns="0" anchor="t"/>
+          <a:lstStyle/>
+          <a:p>
+            <a:pPr marL="0" indent="0" algn="l">
+              <a:spcAft>
+                <a:spcPts val="200"/>
+              </a:spcAft>
+              <a:buNone/>
+            </a:pPr>
+            <a:r>
+              <a:rPr lang="en-US" sz="1200" b="1" dirty="0">
+                <a:solidFill>
+                  <a:srgbClr val="14202B"/>
+                </a:solidFill>
+                <a:latin typeface="Inter"/>
+                <a:ea typeface="Inter"/>
+                <a:cs typeface="Inter"/>
+              </a:rPr>
+              <a:t>Organizational Dynamics</a:t>
+            </a:r>
+          </a:p>
+          <a:p>
+            <a:pPr marL="0" indent="0" algn="l">
+              <a:spcAft>
+                <a:spcPts val="0"/>
+              </a:spcAft>
+              <a:buNone/>
+            </a:pPr>
+            <a:r>
+              <a:rPr lang="en-US" sz="1050" dirty="0">
+                <a:solidFill>
+                  <a:srgbClr val="33424D"/>
+                </a:solidFill>
+                <a:latin typeface="Inter"/>
+                <a:ea typeface="Inter"/>
+                <a:cs typeface="Inter"/>
+              </a:rPr>
+              <a:t>Account for power, roles and workflow effects</a:t>
+            </a:r>
+          </a:p>
+        </p:txBody>
+      </p:sp>
+      <p:sp>
+        <p:nvSpPr>
+          <p:cNvPr id="212" name="Shape 212"/>
+          <p:cNvSpPr/>
+          <p:nvPr/>
+        </p:nvSpPr>
+        <p:spPr>
+          <a:xfrm>
+            <a:off x="8016240" y="2377440"/>
+            <a:ext cx="3322320" cy="3794760"/>
+          </a:xfrm>
+          <a:prstGeom prst="roundRect">
+            <a:avLst>
+              <a:gd name="adj" fmla="val 4000"/>
+            </a:avLst>
+          </a:prstGeom>
+          <a:solidFill>
+            <a:srgbClr val="FFFFFF"/>
+          </a:solidFill>
+          <a:ln w="12700">
+            <a:solidFill>
+              <a:srgbClr val="DCE8E5"/>
+            </a:solidFill>
+          </a:ln>
+        </p:spPr>
+        <p:txBody>
+          <a:bodyPr wrap="square" lIns="0" tIns="0" rIns="0" bIns="0" anchor="t"/>
+          <a:lstStyle/>
+          <a:p>
+            <a:endParaRPr lang="en-US"/>
+          </a:p>
+        </p:txBody>
+      </p:sp>
+      <p:sp>
+        <p:nvSpPr>
+          <p:cNvPr id="213" name="Shape 213"/>
+          <p:cNvSpPr/>
+          <p:nvPr/>
+        </p:nvSpPr>
+        <p:spPr>
+          <a:xfrm>
+            <a:off x="8199120" y="2542032"/>
+            <a:ext cx="2956560" cy="320040"/>
+          </a:xfrm>
+          <a:prstGeom prst="roundRect">
+            <a:avLst>
+              <a:gd name="adj" fmla="val 50000"/>
+            </a:avLst>
+          </a:prstGeom>
+          <a:solidFill>
+            <a:srgbClr val="FEF3DD"/>
+          </a:solidFill>
+          <a:ln w="12700">
+            <a:solidFill>
+              <a:srgbClr val="F3DDA8"/>
+            </a:solidFill>
+          </a:ln>
+        </p:spPr>
+        <p:txBody>
+          <a:bodyPr wrap="square" lIns="0" tIns="0" rIns="0" bIns="0" anchor="ctr"/>
+          <a:lstStyle/>
+          <a:p>
+            <a:pPr marL="0" indent="0" algn="ctr">
+              <a:spcAft>
+                <a:spcPts val="0"/>
+              </a:spcAft>
+              <a:buNone/>
+            </a:pPr>
+            <a:r>
+              <a:rPr lang="en-US" sz="1000" b="1" spc="100" dirty="0">
+                <a:solidFill>
+                  <a:srgbClr val="8A5A00"/>
+                </a:solidFill>
+                <a:latin typeface="IBM Plex Mono"/>
+                <a:ea typeface="IBM Plex Mono"/>
+                <a:cs typeface="IBM Plex Mono"/>
+              </a:rPr>
+              <a:t>CAPABILITY &amp; OBLIGATIONS</a:t>
+            </a:r>
+          </a:p>
+        </p:txBody>
+      </p:sp>
+      <p:sp>
+        <p:nvSpPr>
+          <p:cNvPr id="214" name="Shape 214"/>
+          <p:cNvSpPr/>
+          <p:nvPr/>
+        </p:nvSpPr>
+        <p:spPr>
+          <a:xfrm>
+            <a:off x="8244840" y="3017520"/>
+            <a:ext cx="2865120" cy="680000"/>
+          </a:xfrm>
+          <a:prstGeom prst="rect">
+            <a:avLst/>
+          </a:prstGeom>
+          <a:noFill/>
+          <a:ln>
+            <a:noFill/>
+          </a:ln>
+        </p:spPr>
+        <p:txBody>
+          <a:bodyPr wrap="square" lIns="0" tIns="0" rIns="0" bIns="0" anchor="t"/>
+          <a:lstStyle/>
+          <a:p>
+            <a:pPr marL="0" indent="0" algn="l">
+              <a:spcAft>
+                <a:spcPts val="200"/>
+              </a:spcAft>
+              <a:buNone/>
+            </a:pPr>
+            <a:r>
+              <a:rPr lang="en-US" sz="1200" b="1" dirty="0">
+                <a:solidFill>
+                  <a:srgbClr val="14202B"/>
+                </a:solidFill>
+                <a:latin typeface="Inter"/>
+                <a:ea typeface="Inter"/>
+                <a:cs typeface="Inter"/>
+              </a:rPr>
+              <a:t>Workforce Development / HRM</a:t>
+            </a:r>
+          </a:p>
+          <a:p>
+            <a:pPr marL="0" indent="0" algn="l">
+              <a:spcAft>
+                <a:spcPts val="0"/>
+              </a:spcAft>
+              <a:buNone/>
+            </a:pPr>
+            <a:r>
+              <a:rPr lang="en-US" sz="1050" dirty="0">
+                <a:solidFill>
+                  <a:srgbClr val="33424D"/>
+                </a:solidFill>
+                <a:latin typeface="Inter"/>
+                <a:ea typeface="Inter"/>
+                <a:cs typeface="Inter"/>
+              </a:rPr>
+              <a:t>Up-skill people; guard fairness when HR uses AI</a:t>
+            </a:r>
+          </a:p>
+        </p:txBody>
+      </p:sp>
+      <p:sp>
+        <p:nvSpPr>
+          <p:cNvPr id="215" name="Shape 215"/>
+          <p:cNvSpPr/>
+          <p:nvPr/>
+        </p:nvSpPr>
+        <p:spPr>
+          <a:xfrm>
+            <a:off x="8244840" y="3737520"/>
+            <a:ext cx="2865120" cy="680000"/>
+          </a:xfrm>
+          <a:prstGeom prst="rect">
+            <a:avLst/>
+          </a:prstGeom>
+          <a:noFill/>
+          <a:ln>
+            <a:noFill/>
+          </a:ln>
+        </p:spPr>
+        <p:txBody>
+          <a:bodyPr wrap="square" lIns="0" tIns="0" rIns="0" bIns="0" anchor="t"/>
+          <a:lstStyle/>
+          <a:p>
+            <a:pPr marL="0" indent="0" algn="l">
+              <a:spcAft>
+                <a:spcPts val="200"/>
+              </a:spcAft>
+              <a:buNone/>
+            </a:pPr>
+            <a:r>
+              <a:rPr lang="en-US" sz="1200" b="1" dirty="0">
+                <a:solidFill>
+                  <a:srgbClr val="14202B"/>
+                </a:solidFill>
+                <a:latin typeface="Inter"/>
+                <a:ea typeface="Inter"/>
+                <a:cs typeface="Inter"/>
+              </a:rPr>
+              <a:t>Sustainability</a:t>
+            </a:r>
+          </a:p>
+          <a:p>
+            <a:pPr marL="0" indent="0" algn="l">
+              <a:spcAft>
+                <a:spcPts val="0"/>
+              </a:spcAft>
+              <a:buNone/>
+            </a:pPr>
+            <a:r>
+              <a:rPr lang="en-US" sz="1050" dirty="0">
+                <a:solidFill>
+                  <a:srgbClr val="33424D"/>
+                </a:solidFill>
+                <a:latin typeface="Inter"/>
+                <a:ea typeface="Inter"/>
+                <a:cs typeface="Inter"/>
+              </a:rPr>
+              <a:t>Weigh environmental and long-term societal impact</a:t>
+            </a:r>
+          </a:p>
+        </p:txBody>
+      </p:sp>
+      <p:sp>
+        <p:nvSpPr>
+          <p:cNvPr id="216" name="Shape 216"/>
+          <p:cNvSpPr/>
+          <p:nvPr/>
+        </p:nvSpPr>
+        <p:spPr>
+          <a:xfrm>
+            <a:off x="8244840" y="4457520"/>
+            <a:ext cx="2865120" cy="680000"/>
+          </a:xfrm>
+          <a:prstGeom prst="rect">
+            <a:avLst/>
+          </a:prstGeom>
+          <a:noFill/>
+          <a:ln>
+            <a:noFill/>
+          </a:ln>
+        </p:spPr>
+        <p:txBody>
+          <a:bodyPr wrap="square" lIns="0" tIns="0" rIns="0" bIns="0" anchor="t"/>
+          <a:lstStyle/>
+          <a:p>
+            <a:pPr marL="0" indent="0" algn="l">
+              <a:spcAft>
+                <a:spcPts val="200"/>
+              </a:spcAft>
+              <a:buNone/>
+            </a:pPr>
+            <a:r>
+              <a:rPr lang="en-US" sz="1200" b="1" dirty="0">
+                <a:solidFill>
+                  <a:srgbClr val="14202B"/>
+                </a:solidFill>
+                <a:latin typeface="Inter"/>
+                <a:ea typeface="Inter"/>
+                <a:cs typeface="Inter"/>
+              </a:rPr>
+              <a:t>Legal</a:t>
+            </a:r>
+          </a:p>
+          <a:p>
+            <a:pPr marL="0" indent="0" algn="l">
+              <a:spcAft>
+                <a:spcPts val="0"/>
+              </a:spcAft>
+              <a:buNone/>
+            </a:pPr>
+            <a:r>
+              <a:rPr lang="en-US" sz="1050" dirty="0">
+                <a:solidFill>
+                  <a:srgbClr val="33424D"/>
+                </a:solidFill>
+                <a:latin typeface="Inter"/>
+                <a:ea typeface="Inter"/>
+                <a:cs typeface="Inter"/>
+              </a:rPr>
+              <a:t>Map regulatory and compliance duties</a:t>
+            </a:r>
+          </a:p>
+        </p:txBody>
+      </p:sp>
+      <p:sp>
+        <p:nvSpPr>
+          <p:cNvPr id="217" name="Shape 217"/>
+          <p:cNvSpPr/>
+          <p:nvPr/>
+        </p:nvSpPr>
+        <p:spPr>
+          <a:xfrm>
+            <a:off x="8244840" y="5177520"/>
+            <a:ext cx="2865120" cy="680000"/>
+          </a:xfrm>
+          <a:prstGeom prst="rect">
+            <a:avLst/>
+          </a:prstGeom>
+          <a:noFill/>
+          <a:ln>
+            <a:noFill/>
+          </a:ln>
+        </p:spPr>
+        <p:txBody>
+          <a:bodyPr wrap="square" lIns="0" tIns="0" rIns="0" bIns="0" anchor="t"/>
+          <a:lstStyle/>
+          <a:p>
+            <a:pPr marL="0" indent="0" algn="l">
+              <a:spcAft>
+                <a:spcPts val="200"/>
+              </a:spcAft>
+              <a:buNone/>
+            </a:pPr>
+            <a:r>
+              <a:rPr lang="en-US" sz="1200" b="1" dirty="0">
+                <a:solidFill>
+                  <a:srgbClr val="14202B"/>
+                </a:solidFill>
+                <a:latin typeface="Inter"/>
+                <a:ea typeface="Inter"/>
+                <a:cs typeface="Inter"/>
+              </a:rPr>
+              <a:t>Intellectual property &amp; ownership</a:t>
+            </a:r>
+          </a:p>
+          <a:p>
+            <a:pPr marL="0" indent="0" algn="l">
+              <a:spcAft>
+                <a:spcPts val="0"/>
+              </a:spcAft>
+              <a:buNone/>
+            </a:pPr>
+            <a:r>
+              <a:rPr lang="en-US" sz="1050" dirty="0">
+                <a:solidFill>
+                  <a:srgbClr val="33424D"/>
+                </a:solidFill>
+                <a:latin typeface="Inter"/>
+                <a:ea typeface="Inter"/>
+                <a:cs typeface="Inter"/>
+              </a:rPr>
+              <a:t>Clarify who owns AI inputs, outputs and data</a:t>
+            </a:r>
+          </a:p>
+        </p:txBody>
+      </p:sp>
+      <p:sp>
+        <p:nvSpPr>
+          <p:cNvPr id="25" name="Text 18"/>
+          <p:cNvSpPr/>
+          <p:nvPr/>
+        </p:nvSpPr>
+        <p:spPr>
+          <a:xfrm>
+            <a:off x="822960" y="6419088"/>
+            <a:ext cx="10515600" cy="274320"/>
+          </a:xfrm>
+          <a:prstGeom prst="rect">
+            <a:avLst/>
+          </a:prstGeom>
+          <a:noFill/>
+          <a:ln/>
+        </p:spPr>
+        <p:txBody>
+          <a:bodyPr wrap="square" rtlCol="0" anchor="ctr"/>
+          <a:lstStyle/>
+          <a:p>
+            <a:pPr marL="0" indent="0" algn="l">
+              <a:buNone/>
+            </a:pPr>
+            <a:r>
+              <a:rPr lang="en-US" sz="900" dirty="0">
+                <a:solidFill>
+                  <a:srgbClr val="5B6B77"/>
+                </a:solidFill>
+                <a:latin typeface="Inter" pitchFamily="34" charset="0"/>
+                <a:ea typeface="Inter" pitchFamily="34" charset="-122"/>
+                <a:cs typeface="Inter" pitchFamily="34" charset="-120"/>
+              </a:rPr>
+              <a:t>Reflexive AI Research Initiative · Lucid Institute for Organizational Science</a:t>
+            </a:r>
+            <a:endParaRPr lang="en-US" sz="900" dirty="0"/>
+          </a:p>
+        </p:txBody>
+      </p:sp>
+    </p:spTree>
+  </p:cSld>
+  <p:clrMapOvr>
+    <a:masterClrMapping/>
+  </p:clrMapOvr>
+</p:sld>
+</file>
+
+<file path=ppt/slides/slide9.xml><?xml version="1.0" encoding="utf-8"?>
 <p:sld xmlns:a="http://schemas.openxmlformats.org/drawingml/2006/main" xmlns:r="http://schemas.openxmlformats.org/officeDocument/2006/relationships" xmlns:p="http://schemas.openxmlformats.org/presentationml/2006/main">
   <p:cSld name="Slide 7">
     <p:bg>
@@ -5324,7 +7224,7 @@
                 <a:ea typeface="Sora" pitchFamily="34" charset="-122"/>
                 <a:cs typeface="Sora" pitchFamily="34" charset="-120"/>
               </a:rPr>
-              <a:t>From insight to responsible practice</a:t>
+              <a:t>Now its up to us to create concrete help for organizations</a:t>
             </a:r>
             <a:endParaRPr lang="en-US" sz="4000" dirty="0"/>
           </a:p>

</xml_diff>

<commit_message>
Combined the themes from Tavantzis et al (2027) with the results from the expert interviews by Zelal Kaskin.
</commit_message>
<xml_diff>
--- a/Work Group Guide/Source/Research Presentation.pptx
+++ b/Work Group Guide/Source/Research Presentation.pptx
@@ -5,7 +5,7 @@
     <p:sldMasterId id="2147483648" r:id="rId1"/>
   </p:sldMasterIdLst>
   <p:notesMasterIdLst>
-    <p:notesMasterId r:id="rId11"/>
+    <p:notesMasterId r:id="rId12"/>
   </p:notesMasterIdLst>
   <p:sldIdLst>
     <p:sldId id="256" r:id="rId2"/>
@@ -15,26 +15,27 @@
     <p:sldId id="260" r:id="rId6"/>
     <p:sldId id="261" r:id="rId7"/>
     <p:sldId id="263" r:id="rId8"/>
-    <p:sldId id="264" r:id="rId9"/>
-    <p:sldId id="262" r:id="rId10"/>
+    <p:sldId id="265" r:id="rId9"/>
+    <p:sldId id="264" r:id="rId10"/>
+    <p:sldId id="262" r:id="rId11"/>
   </p:sldIdLst>
   <p:sldSz cx="12192000" cy="6858000"/>
   <p:notesSz cx="6858000" cy="12192000"/>
   <p:embeddedFontLst>
     <p:embeddedFont>
       <p:font typeface="IBM Plex Mono" panose="020B0509050203000203" pitchFamily="49" charset="0"/>
-      <p:regular r:id="rId12"/>
-      <p:bold r:id="rId13"/>
+      <p:regular r:id="rId13"/>
+      <p:bold r:id="rId14"/>
     </p:embeddedFont>
     <p:embeddedFont>
       <p:font typeface="Inter"/>
-      <p:regular r:id="rId14"/>
-      <p:bold r:id="rId15"/>
+      <p:regular r:id="rId15"/>
+      <p:bold r:id="rId16"/>
     </p:embeddedFont>
     <p:embeddedFont>
       <p:font typeface="Sora" pitchFamily="2" charset="0"/>
-      <p:regular r:id="rId16"/>
-      <p:bold r:id="rId17"/>
+      <p:regular r:id="rId17"/>
+      <p:bold r:id="rId18"/>
     </p:embeddedFont>
   </p:embeddedFontLst>
   <p:defaultTextStyle>
@@ -810,7 +811,418 @@
           <a:bodyPr/>
           <a:lstStyle/>
           <a:p>
+            <a:r>
+              <a:rPr lang="en-US" dirty="0"/>
+              <a:t>FULL GUIDING QUESTIONS PER THEME</a:t>
+            </a:r>
+          </a:p>
+          <a:p>
+            <a:r>
+              <a:rPr lang="en-US" dirty="0"/>
+              <a:t>Sources: T = Tavantzis et al., 2027 (9 dimensions, design principles, survey N=105, workshops N=4) · K = Kaskin expert interviews (N=10) · I = Initiative's earlier slide-8 themes</a:t>
+            </a:r>
+          </a:p>
+          <a:p>
             <a:endParaRPr lang="en-US" dirty="0"/>
+          </a:p>
+          <a:p>
+            <a:r>
+              <a:rPr lang="en-US" dirty="0"/>
+              <a:t>DIRECTION &amp; CONTROL</a:t>
+            </a:r>
+          </a:p>
+          <a:p>
+            <a:r>
+              <a:rPr lang="en-US" dirty="0"/>
+              <a:t>1. Purpose &amp; Strategy (T: AI Strategy Design · K1 · I)</a:t>
+            </a:r>
+          </a:p>
+          <a:p>
+            <a:r>
+              <a:rPr lang="en-US" dirty="0"/>
+              <a:t>- What does human-centered AI mean for us: AI as a complementary tool, with people and their dignity as reference point?</a:t>
+            </a:r>
+          </a:p>
+          <a:p>
+            <a:r>
+              <a:rPr lang="en-US" dirty="0"/>
+              <a:t>- Which concrete business and human need does this AI use address? (T: 'recognize a business need' was raised by 7 of 10 interviewees)</a:t>
+            </a:r>
+          </a:p>
+          <a:p>
+            <a:r>
+              <a:rPr lang="en-US" dirty="0"/>
+              <a:t>- Is the solution tailored to our domain and easy to use for the people who work with it?</a:t>
+            </a:r>
+          </a:p>
+          <a:p>
+            <a:r>
+              <a:rPr lang="en-US" dirty="0"/>
+              <a:t>2. Human Agency (K2 · T: Leadership, collective ownership, human retains veto · I: Leadership)</a:t>
+            </a:r>
+          </a:p>
+          <a:p>
+            <a:r>
+              <a:rPr lang="en-US" dirty="0"/>
+              <a:t>- Where does decision authority sit for each AI use, and who is accountable when an AI-influenced decision goes wrong?</a:t>
+            </a:r>
+          </a:p>
+          <a:p>
+            <a:r>
+              <a:rPr lang="en-US" dirty="0"/>
+              <a:t>- Is AI an advisor or a decision-maker here, and how far may AI agents act on their own?</a:t>
+            </a:r>
+          </a:p>
+          <a:p>
+            <a:r>
+              <a:rPr lang="en-US" dirty="0"/>
+              <a:t>- Can employees decide for themselves whether and how they use AI?</a:t>
+            </a:r>
+          </a:p>
+          <a:p>
+            <a:r>
+              <a:rPr lang="en-US" dirty="0"/>
+              <a:t>3. Governance &amp; Ethics (T · K8 · I)</a:t>
+            </a:r>
+          </a:p>
+          <a:p>
+            <a:r>
+              <a:rPr lang="en-US" dirty="0"/>
+              <a:t>- Which guidelines state where AI is not permitted and how sensitive data is handled before prompting?</a:t>
+            </a:r>
+          </a:p>
+          <a:p>
+            <a:r>
+              <a:rPr lang="en-US" dirty="0"/>
+              <a:t>- Who enforces them, through which roles (AI oversight roles, a cross-functional AI unit)?</a:t>
+            </a:r>
+          </a:p>
+          <a:p>
+            <a:r>
+              <a:rPr lang="en-US" dirty="0"/>
+              <a:t>- How do we address shadow AI without excessive control that stalls adoption?</a:t>
+            </a:r>
+          </a:p>
+          <a:p>
+            <a:r>
+              <a:rPr lang="en-US" dirty="0"/>
+              <a:t>4. Review &amp; Adaptation (T: AI Strategy Evaluation · K9 · I: Strategy Evaluation)</a:t>
+            </a:r>
+          </a:p>
+          <a:p>
+            <a:r>
+              <a:rPr lang="en-US" dirty="0"/>
+              <a:t>- Which indicators beyond productivity do we track: harms, rework of AI output, human-oversight ratio, wellbeing?</a:t>
+            </a:r>
+          </a:p>
+          <a:p>
+            <a:r>
+              <a:rPr lang="en-US" dirty="0"/>
+              <a:t>- How often do we reassess AI use, risks and roles, and who takes part?</a:t>
+            </a:r>
+          </a:p>
+          <a:p>
+            <a:r>
+              <a:rPr lang="en-US" dirty="0"/>
+              <a:t>- How do we introduce AI step by step, at a human pace, rather than technology-first?</a:t>
+            </a:r>
+          </a:p>
+          <a:p>
+            <a:endParaRPr lang="en-US" dirty="0"/>
+          </a:p>
+          <a:p>
+            <a:r>
+              <a:rPr lang="en-US" dirty="0"/>
+              <a:t>PEOPLE &amp; WORK</a:t>
+            </a:r>
+          </a:p>
+          <a:p>
+            <a:r>
+              <a:rPr lang="en-US" dirty="0"/>
+              <a:t>5. Meaningful Work (K3 only)</a:t>
+            </a:r>
+          </a:p>
+          <a:p>
+            <a:r>
+              <a:rPr lang="en-US" dirty="0"/>
+              <a:t>- Which tasks keep people feeling needed, competent and connected, and must therefore stay human?</a:t>
+            </a:r>
+          </a:p>
+          <a:p>
+            <a:r>
+              <a:rPr lang="en-US" dirty="0"/>
+              <a:t>- How do roles change, and how do we support job crafting?</a:t>
+            </a:r>
+          </a:p>
+          <a:p>
+            <a:r>
+              <a:rPr lang="en-US" dirty="0"/>
+              <a:t>- Are workload, task switching and pressure rising as people become managers of AI agents?</a:t>
+            </a:r>
+          </a:p>
+          <a:p>
+            <a:r>
+              <a:rPr lang="en-US" dirty="0"/>
+              <a:t>6. Work Design (K4 · T: Collaboration, cross-functional teams · I: Collaboration)</a:t>
+            </a:r>
+          </a:p>
+          <a:p>
+            <a:r>
+              <a:rPr lang="en-US" dirty="0"/>
+              <a:t>- Which tasks go to people and which to AI, and what is AI's defined role in each?</a:t>
+            </a:r>
+          </a:p>
+          <a:p>
+            <a:r>
+              <a:rPr lang="en-US" dirty="0"/>
+              <a:t>- Does the task need close iterative collaboration (restrictive use) or a final human check (loose use)?</a:t>
+            </a:r>
+          </a:p>
+          <a:p>
+            <a:r>
+              <a:rPr lang="en-US" dirty="0"/>
+              <a:t>- Who redesigns the workflow, and are IT, HR, legal and domain experts involved?</a:t>
+            </a:r>
+          </a:p>
+          <a:p>
+            <a:r>
+              <a:rPr lang="en-US" dirty="0"/>
+              <a:t>7. Workforce &amp; Learning (T: Up-skilling · K5 · I: Workforce Development / HRM)</a:t>
+            </a:r>
+          </a:p>
+          <a:p>
+            <a:r>
+              <a:rPr lang="en-US" dirty="0"/>
+              <a:t>- Which skills must people build or preserve: AI literacy, domain expertise, verification, self-regulation?</a:t>
+            </a:r>
+          </a:p>
+          <a:p>
+            <a:r>
+              <a:rPr lang="en-US" dirty="0"/>
+              <a:t>- How do we prevent cognitive deskilling, e.g. skill verification and co-cognition instead of passive use?</a:t>
+            </a:r>
+          </a:p>
+          <a:p>
+            <a:r>
+              <a:rPr lang="en-US" dirty="0"/>
+              <a:t>- Which formats work: hands-on, tailored, cross-generational mentoring rather than passive courses?</a:t>
+            </a:r>
+          </a:p>
+          <a:p>
+            <a:r>
+              <a:rPr lang="en-US" dirty="0"/>
+              <a:t>8. Quality &amp; Oversight (K6 · T: evaluate AI outputs, monitor over-reliance)</a:t>
+            </a:r>
+          </a:p>
+          <a:p>
+            <a:r>
+              <a:rPr lang="en-US" dirty="0"/>
+              <a:t>- Who verifies AI output, how, and against which sources?</a:t>
+            </a:r>
+          </a:p>
+          <a:p>
+            <a:r>
+              <a:rPr lang="en-US" dirty="0"/>
+              <a:t>- How do we detect hallucinations, bias and over-reliance, and does the AI signal uncertainty?</a:t>
+            </a:r>
+          </a:p>
+          <a:p>
+            <a:r>
+              <a:rPr lang="en-US" dirty="0"/>
+              <a:t>- Where must speed yield to precision, knowing agents can break hard rules even when clearly prompted?</a:t>
+            </a:r>
+          </a:p>
+          <a:p>
+            <a:endParaRPr lang="en-US" dirty="0"/>
+          </a:p>
+          <a:p>
+            <a:r>
+              <a:rPr lang="en-US" dirty="0"/>
+              <a:t>CULTURE &amp; VOICE</a:t>
+            </a:r>
+          </a:p>
+          <a:p>
+            <a:r>
+              <a:rPr lang="en-US" dirty="0"/>
+              <a:t>9. Communication (T · K8 transparency · I)</a:t>
+            </a:r>
+          </a:p>
+          <a:p>
+            <a:r>
+              <a:rPr lang="en-US" dirty="0"/>
+              <a:t>- Does everyone know whether we have an AI strategy and what it says? (T: almost 15% of respondents were unsure)</a:t>
+            </a:r>
+          </a:p>
+          <a:p>
+            <a:r>
+              <a:rPr lang="en-US" dirty="0"/>
+              <a:t>- Is it clear where AI is used, how decisions are made and how data is processed?</a:t>
+            </a:r>
+          </a:p>
+          <a:p>
+            <a:r>
+              <a:rPr lang="en-US" dirty="0"/>
+              <a:t>- Which two-way channels let people ask questions and raise concerns?</a:t>
+            </a:r>
+          </a:p>
+          <a:p>
+            <a:r>
+              <a:rPr lang="en-US" dirty="0"/>
+              <a:t>10. Participation (K8: co-design, works council · T: stakeholder engagement, listen to concerns)</a:t>
+            </a:r>
+          </a:p>
+          <a:p>
+            <a:r>
+              <a:rPr lang="en-US" dirty="0"/>
+              <a:t>- How are employees involved in choosing and designing AI uses, not only informed about them?</a:t>
+            </a:r>
+          </a:p>
+          <a:p>
+            <a:r>
+              <a:rPr lang="en-US" dirty="0"/>
+              <a:t>- Is there an independent body, such as a works council, that represents and protects employees?</a:t>
+            </a:r>
+          </a:p>
+          <a:p>
+            <a:r>
+              <a:rPr lang="en-US" dirty="0"/>
+              <a:t>- How can employees challenge or appeal AI-influenced decisions?</a:t>
+            </a:r>
+          </a:p>
+          <a:p>
+            <a:r>
+              <a:rPr lang="en-US" dirty="0"/>
+              <a:t>11. Questioning Culture (T: Organizational Culture · K5 · I)</a:t>
+            </a:r>
+          </a:p>
+          <a:p>
+            <a:r>
+              <a:rPr lang="en-US" dirty="0"/>
+              <a:t>- Can people experiment and make mistakes with AI without fear?</a:t>
+            </a:r>
+          </a:p>
+          <a:p>
+            <a:r>
+              <a:rPr lang="en-US" dirty="0"/>
+              <a:t>- Does top-down pressure for speed crowd out learning and reflection?</a:t>
+            </a:r>
+          </a:p>
+          <a:p>
+            <a:r>
+              <a:rPr lang="en-US" dirty="0"/>
+              <a:t>- Is it legitimate to question or reject AI output?</a:t>
+            </a:r>
+          </a:p>
+          <a:p>
+            <a:r>
+              <a:rPr lang="en-US" dirty="0"/>
+              <a:t>12. Power &amp; Dynamics (T: Organizational Dynamics · I)</a:t>
+            </a:r>
+          </a:p>
+          <a:p>
+            <a:r>
+              <a:rPr lang="en-US" dirty="0"/>
+              <a:t>- Whose interests drive AI adoption, and who gains or loses influence?</a:t>
+            </a:r>
+          </a:p>
+          <a:p>
+            <a:r>
+              <a:rPr lang="en-US" dirty="0"/>
+              <a:t>- Where do differing views and resistance come from, and what do they tell us?</a:t>
+            </a:r>
+          </a:p>
+          <a:p>
+            <a:r>
+              <a:rPr lang="en-US" dirty="0"/>
+              <a:t>- Is the timing right given internal pressures? (T: ranked lowest in the survey, although differing views were a frequent challenge)</a:t>
+            </a:r>
+          </a:p>
+          <a:p>
+            <a:endParaRPr lang="en-US" dirty="0"/>
+          </a:p>
+          <a:p>
+            <a:r>
+              <a:rPr lang="en-US" dirty="0"/>
+              <a:t>BOUNDARIES &amp; DUTIES</a:t>
+            </a:r>
+          </a:p>
+          <a:p>
+            <a:r>
+              <a:rPr lang="en-US" dirty="0"/>
+              <a:t>13. Risk &amp; Boundaries (K7 · T: risk aversion due to sensitive data, the most-cited survey challenge)</a:t>
+            </a:r>
+          </a:p>
+          <a:p>
+            <a:r>
+              <a:rPr lang="en-US" dirty="0"/>
+              <a:t>- Which contexts need restrictions and more human involvement: health, HR, public sector, client-facing work?</a:t>
+            </a:r>
+          </a:p>
+          <a:p>
+            <a:r>
+              <a:rPr lang="en-US" dirty="0"/>
+              <a:t>- Which organizational data may AI agents access, mirroring employees' access rights?</a:t>
+            </a:r>
+          </a:p>
+          <a:p>
+            <a:r>
+              <a:rPr lang="en-US" dirty="0"/>
+              <a:t>- How do we rule out AI-enabled monitoring and surveillance of employees?</a:t>
+            </a:r>
+          </a:p>
+          <a:p>
+            <a:r>
+              <a:rPr lang="en-US" dirty="0"/>
+              <a:t>14. Legal &amp; Compliance (T: external environment, regulation · K8 · I)</a:t>
+            </a:r>
+          </a:p>
+          <a:p>
+            <a:r>
+              <a:rPr lang="en-US" dirty="0"/>
+              <a:t>- Which rules apply to each use: EU AI Act transparency and human oversight, GDPR, sector rules?</a:t>
+            </a:r>
+          </a:p>
+          <a:p>
+            <a:r>
+              <a:rPr lang="en-US" dirty="0"/>
+              <a:t>- Who monitors regulatory change and translates it into our guidelines?</a:t>
+            </a:r>
+          </a:p>
+          <a:p>
+            <a:r>
+              <a:rPr lang="en-US" dirty="0"/>
+              <a:t>15. IP &amp; Data Ownership (I · T: anonymize proprietary data, provide internal AI solutions)</a:t>
+            </a:r>
+          </a:p>
+          <a:p>
+            <a:r>
+              <a:rPr lang="en-US" dirty="0"/>
+              <a:t>- Who owns AI inputs, outputs and derived data?</a:t>
+            </a:r>
+          </a:p>
+          <a:p>
+            <a:r>
+              <a:rPr lang="en-US" dirty="0"/>
+              <a:t>- What may leave the organization through external AI tools, and when do we need internal solutions?</a:t>
+            </a:r>
+          </a:p>
+          <a:p>
+            <a:r>
+              <a:rPr lang="en-US" dirty="0"/>
+              <a:t>16. Sustainability (I · K7 environmental impact)</a:t>
+            </a:r>
+          </a:p>
+          <a:p>
+            <a:r>
+              <a:rPr lang="en-US" dirty="0"/>
+              <a:t>- What is the environmental footprint of our AI use, and is it proportionate to the benefit?</a:t>
+            </a:r>
+          </a:p>
+          <a:p>
+            <a:r>
+              <a:rPr lang="en-US" dirty="0"/>
+              <a:t>- What are the long-term societal effects, for example on jobs and inequality?</a:t>
+            </a:r>
           </a:p>
         </p:txBody>
       </p:sp>
@@ -831,7 +1243,86 @@
           <a:p>
             <a:fld id="{F7021451-1387-4CA6-816F-3879F97B5CBC}" type="slidenum">
               <a:rPr lang="en-US"/>
-              <a:t>9</a:t>
+              <a:t>8</a:t>
+            </a:fld>
+            <a:endParaRPr lang="en-US"/>
+          </a:p>
+        </p:txBody>
+      </p:sp>
+    </p:spTree>
+  </p:cSld>
+  <p:clrMapOvr>
+    <a:masterClrMapping/>
+  </p:clrMapOvr>
+</p:notes>
+</file>
+
+<file path=ppt/notesSlides/notesSlide8.xml><?xml version="1.0" encoding="utf-8"?>
+<p:notes xmlns:a="http://schemas.openxmlformats.org/drawingml/2006/main" xmlns:r="http://schemas.openxmlformats.org/officeDocument/2006/relationships" xmlns:p="http://schemas.openxmlformats.org/presentationml/2006/main">
+  <p:cSld>
+    <p:spTree>
+      <p:nvGrpSpPr>
+        <p:cNvPr id="1" name=""/>
+        <p:cNvGrpSpPr/>
+        <p:nvPr/>
+      </p:nvGrpSpPr>
+      <p:grpSpPr>
+        <a:xfrm>
+          <a:off x="0" y="0"/>
+          <a:ext cx="0" cy="0"/>
+          <a:chOff x="0" y="0"/>
+          <a:chExt cx="0" cy="0"/>
+        </a:xfrm>
+      </p:grpSpPr>
+      <p:sp>
+        <p:nvSpPr>
+          <p:cNvPr id="2" name="Slide Image Placeholder 1"/>
+          <p:cNvSpPr>
+            <a:spLocks noGrp="1" noRot="1" noChangeAspect="1"/>
+          </p:cNvSpPr>
+          <p:nvPr>
+            <p:ph type="sldImg"/>
+          </p:nvPr>
+        </p:nvSpPr>
+        <p:spPr/>
+      </p:sp>
+      <p:sp>
+        <p:nvSpPr>
+          <p:cNvPr id="3" name="Notes Placeholder 2"/>
+          <p:cNvSpPr>
+            <a:spLocks noGrp="1"/>
+          </p:cNvSpPr>
+          <p:nvPr>
+            <p:ph type="body" idx="1"/>
+          </p:nvPr>
+        </p:nvSpPr>
+        <p:spPr/>
+        <p:txBody>
+          <a:bodyPr/>
+          <a:lstStyle/>
+          <a:p>
+            <a:endParaRPr lang="en-US" dirty="0"/>
+          </a:p>
+        </p:txBody>
+      </p:sp>
+      <p:sp>
+        <p:nvSpPr>
+          <p:cNvPr id="4" name="Slide Number Placeholder 3"/>
+          <p:cNvSpPr>
+            <a:spLocks noGrp="1"/>
+          </p:cNvSpPr>
+          <p:nvPr>
+            <p:ph type="sldNum" sz="quarter" idx="10"/>
+          </p:nvPr>
+        </p:nvSpPr>
+        <p:spPr/>
+        <p:txBody>
+          <a:bodyPr/>
+          <a:lstStyle/>
+          <a:p>
+            <a:fld id="{F7021451-1387-4CA6-816F-3879F97B5CBC}" type="slidenum">
+              <a:rPr lang="en-US"/>
+              <a:t>10</a:t>
             </a:fld>
             <a:endParaRPr lang="en-US"/>
           </a:p>
@@ -1591,6 +2082,261 @@
 </p:sld>
 </file>
 
+<file path=ppt/slides/slide10.xml><?xml version="1.0" encoding="utf-8"?>
+<p:sld xmlns:a="http://schemas.openxmlformats.org/drawingml/2006/main" xmlns:r="http://schemas.openxmlformats.org/officeDocument/2006/relationships" xmlns:p="http://schemas.openxmlformats.org/presentationml/2006/main">
+  <p:cSld name="Slide 7">
+    <p:bg>
+      <p:bgPr>
+        <a:solidFill>
+          <a:srgbClr val="0B444A"/>
+        </a:solidFill>
+        <a:effectLst/>
+      </p:bgPr>
+    </p:bg>
+    <p:spTree>
+      <p:nvGrpSpPr>
+        <p:cNvPr id="1" name=""/>
+        <p:cNvGrpSpPr/>
+        <p:nvPr/>
+      </p:nvGrpSpPr>
+      <p:grpSpPr>
+        <a:xfrm>
+          <a:off x="0" y="0"/>
+          <a:ext cx="0" cy="0"/>
+          <a:chOff x="0" y="0"/>
+          <a:chExt cx="0" cy="0"/>
+        </a:xfrm>
+      </p:grpSpPr>
+      <p:pic>
+        <p:nvPicPr>
+          <p:cNvPr id="2" name="Image 0" descr="preencoded.png"/>
+          <p:cNvPicPr>
+            <a:picLocks noChangeAspect="1"/>
+          </p:cNvPicPr>
+          <p:nvPr/>
+        </p:nvPicPr>
+        <p:blipFill>
+          <a:blip r:embed="rId3"/>
+          <a:stretch>
+            <a:fillRect/>
+          </a:stretch>
+        </p:blipFill>
+        <p:spPr>
+          <a:xfrm>
+            <a:off x="0" y="0"/>
+            <a:ext cx="12191695" cy="6858000"/>
+          </a:xfrm>
+          <a:prstGeom prst="rect">
+            <a:avLst/>
+          </a:prstGeom>
+        </p:spPr>
+      </p:pic>
+      <p:sp>
+        <p:nvSpPr>
+          <p:cNvPr id="3" name="Shape 0"/>
+          <p:cNvSpPr/>
+          <p:nvPr/>
+        </p:nvSpPr>
+        <p:spPr>
+          <a:xfrm>
+            <a:off x="0" y="0"/>
+            <a:ext cx="4063898" cy="146304"/>
+          </a:xfrm>
+          <a:prstGeom prst="rect">
+            <a:avLst/>
+          </a:prstGeom>
+          <a:solidFill>
+            <a:srgbClr val="0F9E8E"/>
+          </a:solidFill>
+          <a:ln/>
+        </p:spPr>
+        <p:txBody>
+          <a:bodyPr/>
+          <a:lstStyle/>
+          <a:p>
+            <a:endParaRPr lang="LID4096"/>
+          </a:p>
+        </p:txBody>
+      </p:sp>
+      <p:sp>
+        <p:nvSpPr>
+          <p:cNvPr id="4" name="Shape 1"/>
+          <p:cNvSpPr/>
+          <p:nvPr/>
+        </p:nvSpPr>
+        <p:spPr>
+          <a:xfrm>
+            <a:off x="4063898" y="0"/>
+            <a:ext cx="4063898" cy="146304"/>
+          </a:xfrm>
+          <a:prstGeom prst="rect">
+            <a:avLst/>
+          </a:prstGeom>
+          <a:solidFill>
+            <a:srgbClr val="2B3F9E"/>
+          </a:solidFill>
+          <a:ln/>
+        </p:spPr>
+        <p:txBody>
+          <a:bodyPr/>
+          <a:lstStyle/>
+          <a:p>
+            <a:endParaRPr lang="LID4096"/>
+          </a:p>
+        </p:txBody>
+      </p:sp>
+      <p:sp>
+        <p:nvSpPr>
+          <p:cNvPr id="5" name="Shape 2"/>
+          <p:cNvSpPr/>
+          <p:nvPr/>
+        </p:nvSpPr>
+        <p:spPr>
+          <a:xfrm>
+            <a:off x="8127797" y="0"/>
+            <a:ext cx="4063898" cy="146304"/>
+          </a:xfrm>
+          <a:prstGeom prst="rect">
+            <a:avLst/>
+          </a:prstGeom>
+          <a:solidFill>
+            <a:srgbClr val="F5A623"/>
+          </a:solidFill>
+          <a:ln/>
+        </p:spPr>
+        <p:txBody>
+          <a:bodyPr/>
+          <a:lstStyle/>
+          <a:p>
+            <a:endParaRPr lang="LID4096"/>
+          </a:p>
+        </p:txBody>
+      </p:sp>
+      <p:sp>
+        <p:nvSpPr>
+          <p:cNvPr id="6" name="Text 3"/>
+          <p:cNvSpPr/>
+          <p:nvPr/>
+        </p:nvSpPr>
+        <p:spPr>
+          <a:xfrm>
+            <a:off x="822960" y="2468880"/>
+            <a:ext cx="9144000" cy="365760"/>
+          </a:xfrm>
+          <a:prstGeom prst="rect">
+            <a:avLst/>
+          </a:prstGeom>
+          <a:noFill/>
+          <a:ln/>
+        </p:spPr>
+        <p:txBody>
+          <a:bodyPr wrap="square" rtlCol="0" anchor="ctr"/>
+          <a:lstStyle/>
+          <a:p>
+            <a:pPr marL="0" indent="0" algn="l">
+              <a:buNone/>
+            </a:pPr>
+            <a:r>
+              <a:rPr lang="en-US" sz="1300" b="1" kern="0" spc="400" dirty="0">
+                <a:solidFill>
+                  <a:srgbClr val="5EE6D6"/>
+                </a:solidFill>
+                <a:latin typeface="IBM Plex Mono" pitchFamily="34" charset="0"/>
+                <a:ea typeface="IBM Plex Mono" pitchFamily="34" charset="-122"/>
+                <a:cs typeface="IBM Plex Mono" pitchFamily="34" charset="-120"/>
+              </a:rPr>
+              <a:t>THANK YOU</a:t>
+            </a:r>
+            <a:endParaRPr lang="en-US" sz="1300" dirty="0"/>
+          </a:p>
+        </p:txBody>
+      </p:sp>
+      <p:sp>
+        <p:nvSpPr>
+          <p:cNvPr id="7" name="Text 4"/>
+          <p:cNvSpPr/>
+          <p:nvPr/>
+        </p:nvSpPr>
+        <p:spPr>
+          <a:xfrm>
+            <a:off x="786384" y="2926080"/>
+            <a:ext cx="10515600" cy="1005840"/>
+          </a:xfrm>
+          <a:prstGeom prst="rect">
+            <a:avLst/>
+          </a:prstGeom>
+          <a:noFill/>
+          <a:ln/>
+        </p:spPr>
+        <p:txBody>
+          <a:bodyPr wrap="square" rtlCol="0" anchor="ctr"/>
+          <a:lstStyle/>
+          <a:p>
+            <a:pPr marL="0" indent="0" algn="l">
+              <a:buNone/>
+            </a:pPr>
+            <a:r>
+              <a:rPr lang="en-US" sz="4000" b="1" dirty="0">
+                <a:solidFill>
+                  <a:srgbClr val="FFFFFF"/>
+                </a:solidFill>
+                <a:latin typeface="Sora" pitchFamily="34" charset="0"/>
+                <a:ea typeface="Sora" pitchFamily="34" charset="-122"/>
+                <a:cs typeface="Sora" pitchFamily="34" charset="-120"/>
+              </a:rPr>
+              <a:t>Now its up to us to create concrete help for organizations</a:t>
+            </a:r>
+            <a:endParaRPr lang="en-US" sz="4000" dirty="0"/>
+          </a:p>
+        </p:txBody>
+      </p:sp>
+      <p:sp>
+        <p:nvSpPr>
+          <p:cNvPr id="8" name="Text 5"/>
+          <p:cNvSpPr/>
+          <p:nvPr/>
+        </p:nvSpPr>
+        <p:spPr>
+          <a:xfrm>
+            <a:off x="822960" y="6419088"/>
+            <a:ext cx="10515600" cy="274320"/>
+          </a:xfrm>
+          <a:prstGeom prst="rect">
+            <a:avLst/>
+          </a:prstGeom>
+          <a:noFill/>
+          <a:ln/>
+        </p:spPr>
+        <p:txBody>
+          <a:bodyPr wrap="square" rtlCol="0" anchor="ctr"/>
+          <a:lstStyle/>
+          <a:p>
+            <a:pPr marL="0" indent="0" algn="l">
+              <a:buNone/>
+            </a:pPr>
+            <a:r>
+              <a:rPr lang="en-US" sz="900" dirty="0">
+                <a:solidFill>
+                  <a:srgbClr val="A9BCCB"/>
+                </a:solidFill>
+                <a:latin typeface="Inter" pitchFamily="34" charset="0"/>
+                <a:ea typeface="Inter" pitchFamily="34" charset="-122"/>
+                <a:cs typeface="Inter" pitchFamily="34" charset="-120"/>
+              </a:rPr>
+              <a:t>Reflexive AI Research Initiative · Lucid Institute for Organizational Science</a:t>
+            </a:r>
+            <a:endParaRPr lang="en-US" sz="900" dirty="0"/>
+          </a:p>
+        </p:txBody>
+      </p:sp>
+    </p:spTree>
+  </p:cSld>
+  <p:clrMapOvr>
+    <a:masterClrMapping/>
+  </p:clrMapOvr>
+</p:sld>
+</file>
+
 <file path=ppt/slides/slide2.xml><?xml version="1.0" encoding="utf-8"?>
 <p:sld xmlns:a="http://schemas.openxmlformats.org/drawingml/2006/main" xmlns:r="http://schemas.openxmlformats.org/officeDocument/2006/relationships" xmlns:p="http://schemas.openxmlformats.org/presentationml/2006/main">
   <p:cSld name="Slide 2">
@@ -5778,6 +6524,1811 @@
 
 <file path=ppt/slides/slide8.xml><?xml version="1.0" encoding="utf-8"?>
 <p:sld xmlns:a="http://schemas.openxmlformats.org/drawingml/2006/main" xmlns:r="http://schemas.openxmlformats.org/officeDocument/2006/relationships" xmlns:p="http://schemas.openxmlformats.org/presentationml/2006/main">
+  <p:cSld>
+    <p:spTree>
+      <p:nvGrpSpPr>
+        <p:cNvPr id="1" name=""/>
+        <p:cNvGrpSpPr/>
+        <p:nvPr/>
+      </p:nvGrpSpPr>
+      <p:grpSpPr>
+        <a:xfrm>
+          <a:off x="0" y="0"/>
+          <a:ext cx="0" cy="0"/>
+          <a:chOff x="0" y="0"/>
+          <a:chExt cx="0" cy="0"/>
+        </a:xfrm>
+      </p:grpSpPr>
+      <p:sp>
+        <p:nvSpPr>
+          <p:cNvPr id="2" name="Shape 0"/>
+          <p:cNvSpPr/>
+          <p:nvPr/>
+        </p:nvSpPr>
+        <p:spPr>
+          <a:xfrm>
+            <a:off x="0" y="0"/>
+            <a:ext cx="4063898" cy="146304"/>
+          </a:xfrm>
+          <a:prstGeom prst="rect">
+            <a:avLst/>
+          </a:prstGeom>
+          <a:solidFill>
+            <a:srgbClr val="0F9E8E"/>
+          </a:solidFill>
+          <a:ln/>
+        </p:spPr>
+        <p:txBody>
+          <a:bodyPr/>
+          <a:lstStyle/>
+          <a:p>
+            <a:endParaRPr lang="LID4096"/>
+          </a:p>
+        </p:txBody>
+      </p:sp>
+      <p:sp>
+        <p:nvSpPr>
+          <p:cNvPr id="3" name="Shape 1"/>
+          <p:cNvSpPr/>
+          <p:nvPr/>
+        </p:nvSpPr>
+        <p:spPr>
+          <a:xfrm>
+            <a:off x="4063898" y="0"/>
+            <a:ext cx="4063898" cy="146304"/>
+          </a:xfrm>
+          <a:prstGeom prst="rect">
+            <a:avLst/>
+          </a:prstGeom>
+          <a:solidFill>
+            <a:srgbClr val="2B3F9E"/>
+          </a:solidFill>
+          <a:ln/>
+        </p:spPr>
+        <p:txBody>
+          <a:bodyPr/>
+          <a:lstStyle/>
+          <a:p>
+            <a:endParaRPr lang="LID4096"/>
+          </a:p>
+        </p:txBody>
+      </p:sp>
+      <p:sp>
+        <p:nvSpPr>
+          <p:cNvPr id="4" name="Shape 2"/>
+          <p:cNvSpPr/>
+          <p:nvPr/>
+        </p:nvSpPr>
+        <p:spPr>
+          <a:xfrm>
+            <a:off x="8127797" y="0"/>
+            <a:ext cx="4063898" cy="146304"/>
+          </a:xfrm>
+          <a:prstGeom prst="rect">
+            <a:avLst/>
+          </a:prstGeom>
+          <a:solidFill>
+            <a:srgbClr val="F5A623"/>
+          </a:solidFill>
+          <a:ln/>
+        </p:spPr>
+        <p:txBody>
+          <a:bodyPr/>
+          <a:lstStyle/>
+          <a:p>
+            <a:endParaRPr lang="LID4096"/>
+          </a:p>
+        </p:txBody>
+      </p:sp>
+      <p:sp>
+        <p:nvSpPr>
+          <p:cNvPr id="10" name="Text 7"/>
+          <p:cNvSpPr/>
+          <p:nvPr/>
+        </p:nvSpPr>
+        <p:spPr>
+          <a:xfrm>
+            <a:off x="822960" y="960120"/>
+            <a:ext cx="10515600" cy="365760"/>
+          </a:xfrm>
+          <a:prstGeom prst="rect">
+            <a:avLst/>
+          </a:prstGeom>
+          <a:noFill/>
+          <a:ln/>
+        </p:spPr>
+        <p:txBody>
+          <a:bodyPr wrap="square" rtlCol="0" anchor="ctr"/>
+          <a:lstStyle/>
+          <a:p>
+            <a:pPr marL="0" indent="0" algn="l">
+              <a:buNone/>
+            </a:pPr>
+            <a:r>
+              <a:rPr lang="en-US" sz="1200" b="1" kern="0" spc="200" dirty="0">
+                <a:solidFill>
+                  <a:srgbClr val="0B6F63"/>
+                </a:solidFill>
+                <a:latin typeface="IBM Plex Mono" pitchFamily="34" charset="0"/>
+                <a:ea typeface="IBM Plex Mono" pitchFamily="34" charset="-122"/>
+                <a:cs typeface="IBM Plex Mono" pitchFamily="34" charset="-120"/>
+              </a:rPr>
+              <a:t>GOVERNANCE FRAMEWORK · THEMES FROM LITERATURE REVIEW &amp; EXPERT INTERVIEWS</a:t>
+            </a:r>
+            <a:endParaRPr lang="en-US" sz="1200" dirty="0"/>
+          </a:p>
+        </p:txBody>
+      </p:sp>
+      <p:sp>
+        <p:nvSpPr>
+          <p:cNvPr id="11" name="Text 8"/>
+          <p:cNvSpPr/>
+          <p:nvPr/>
+        </p:nvSpPr>
+        <p:spPr>
+          <a:xfrm>
+            <a:off x="786384" y="1463040"/>
+            <a:ext cx="10515600" cy="1371600"/>
+          </a:xfrm>
+          <a:prstGeom prst="rect">
+            <a:avLst/>
+          </a:prstGeom>
+          <a:noFill/>
+          <a:ln/>
+        </p:spPr>
+        <p:txBody>
+          <a:bodyPr wrap="square" rtlCol="0" anchor="t"/>
+          <a:lstStyle/>
+          <a:p>
+            <a:pPr marL="0" indent="0" algn="l">
+              <a:lnSpc>
+                <a:spcPct val="106000"/>
+              </a:lnSpc>
+              <a:buNone/>
+            </a:pPr>
+            <a:r>
+              <a:rPr lang="en-US" sz="3200" b="1" dirty="0">
+                <a:solidFill>
+                  <a:srgbClr val="14202B"/>
+                </a:solidFill>
+                <a:latin typeface="Sora" pitchFamily="34" charset="0"/>
+                <a:ea typeface="Sora" pitchFamily="34" charset="-122"/>
+                <a:cs typeface="Sora" pitchFamily="34" charset="-120"/>
+              </a:rPr>
+              <a:t>Sixteen </a:t>
+            </a:r>
+            <a:r>
+              <a:rPr lang="en-US" sz="3200" b="1" u="sng" dirty="0">
+                <a:solidFill>
+                  <a:srgbClr val="14202B"/>
+                </a:solidFill>
+                <a:latin typeface="Sora" pitchFamily="34" charset="0"/>
+                <a:ea typeface="Sora" pitchFamily="34" charset="-122"/>
+                <a:cs typeface="Sora" pitchFamily="34" charset="-120"/>
+              </a:rPr>
+              <a:t>starting</a:t>
+            </a:r>
+            <a:r>
+              <a:rPr lang="en-US" sz="3200" b="1" dirty="0">
+                <a:solidFill>
+                  <a:srgbClr val="14202B"/>
+                </a:solidFill>
+                <a:latin typeface="Sora" pitchFamily="34" charset="0"/>
+                <a:ea typeface="Sora" pitchFamily="34" charset="-122"/>
+                <a:cs typeface="Sora" pitchFamily="34" charset="-120"/>
+              </a:rPr>
+              <a:t> themes for human-centered AI</a:t>
+            </a:r>
+            <a:endParaRPr lang="en-US" sz="3200" dirty="0"/>
+          </a:p>
+        </p:txBody>
+      </p:sp>
+      <p:sp>
+        <p:nvSpPr>
+          <p:cNvPr id="301" name="Shape 301"/>
+          <p:cNvSpPr/>
+          <p:nvPr/>
+        </p:nvSpPr>
+        <p:spPr>
+          <a:xfrm>
+            <a:off x="822960" y="2377440"/>
+            <a:ext cx="2457450" cy="3794760"/>
+          </a:xfrm>
+          <a:prstGeom prst="roundRect">
+            <a:avLst>
+              <a:gd name="adj" fmla="val 4000"/>
+            </a:avLst>
+          </a:prstGeom>
+          <a:solidFill>
+            <a:srgbClr val="FFFFFF"/>
+          </a:solidFill>
+          <a:ln w="12700">
+            <a:solidFill>
+              <a:srgbClr val="DCE8E5"/>
+            </a:solidFill>
+          </a:ln>
+        </p:spPr>
+        <p:txBody>
+          <a:bodyPr wrap="square" lIns="0" tIns="0" rIns="0" bIns="0" anchor="t"/>
+          <a:lstStyle/>
+          <a:p>
+            <a:endParaRPr lang="en-US"/>
+          </a:p>
+        </p:txBody>
+      </p:sp>
+      <p:sp>
+        <p:nvSpPr>
+          <p:cNvPr id="302" name="Shape 302"/>
+          <p:cNvSpPr/>
+          <p:nvPr/>
+        </p:nvSpPr>
+        <p:spPr>
+          <a:xfrm>
+            <a:off x="960120" y="2542032"/>
+            <a:ext cx="2183130" cy="320040"/>
+          </a:xfrm>
+          <a:prstGeom prst="roundRect">
+            <a:avLst>
+              <a:gd name="adj" fmla="val 50000"/>
+            </a:avLst>
+          </a:prstGeom>
+          <a:solidFill>
+            <a:srgbClr val="EAF6F3"/>
+          </a:solidFill>
+          <a:ln w="12700">
+            <a:solidFill>
+              <a:srgbClr val="BFE3DC"/>
+            </a:solidFill>
+          </a:ln>
+        </p:spPr>
+        <p:txBody>
+          <a:bodyPr wrap="square" lIns="0" tIns="0" rIns="0" bIns="0" anchor="ctr"/>
+          <a:lstStyle/>
+          <a:p>
+            <a:pPr marL="0" indent="0" algn="ctr">
+              <a:spcAft>
+                <a:spcPts val="0"/>
+              </a:spcAft>
+              <a:buNone/>
+            </a:pPr>
+            <a:r>
+              <a:rPr lang="en-US" sz="900" b="1" spc="80" dirty="0">
+                <a:solidFill>
+                  <a:srgbClr val="0B6F63"/>
+                </a:solidFill>
+                <a:latin typeface="IBM Plex Mono"/>
+                <a:ea typeface="IBM Plex Mono"/>
+                <a:cs typeface="IBM Plex Mono"/>
+              </a:rPr>
+              <a:t>DIRECTION &amp; CONTROL</a:t>
+            </a:r>
+          </a:p>
+        </p:txBody>
+      </p:sp>
+      <p:sp>
+        <p:nvSpPr>
+          <p:cNvPr id="303" name="Shape 303"/>
+          <p:cNvSpPr/>
+          <p:nvPr/>
+        </p:nvSpPr>
+        <p:spPr>
+          <a:xfrm>
+            <a:off x="1005840" y="3017520"/>
+            <a:ext cx="2091690" cy="680000"/>
+          </a:xfrm>
+          <a:prstGeom prst="rect">
+            <a:avLst/>
+          </a:prstGeom>
+          <a:noFill/>
+          <a:ln>
+            <a:noFill/>
+          </a:ln>
+        </p:spPr>
+        <p:txBody>
+          <a:bodyPr wrap="square" lIns="0" tIns="0" rIns="0" bIns="0" anchor="t"/>
+          <a:lstStyle/>
+          <a:p>
+            <a:pPr marL="0" indent="0" algn="l">
+              <a:spcAft>
+                <a:spcPts val="200"/>
+              </a:spcAft>
+              <a:buNone/>
+            </a:pPr>
+            <a:r>
+              <a:rPr lang="en-US" sz="1100" b="1" dirty="0">
+                <a:solidFill>
+                  <a:srgbClr val="14202B"/>
+                </a:solidFill>
+                <a:latin typeface="Inter"/>
+                <a:ea typeface="Inter"/>
+                <a:cs typeface="Inter"/>
+              </a:rPr>
+              <a:t>Purpose &amp; Strategy</a:t>
+            </a:r>
+            <a:r>
+              <a:rPr lang="en-US" sz="750" b="0" dirty="0">
+                <a:solidFill>
+                  <a:srgbClr val="5F6F7A"/>
+                </a:solidFill>
+                <a:latin typeface="Inter"/>
+                <a:ea typeface="Inter"/>
+                <a:cs typeface="Inter"/>
+              </a:rPr>
+              <a:t>  T·K</a:t>
+            </a:r>
+          </a:p>
+          <a:p>
+            <a:pPr marL="0" indent="0" algn="l">
+              <a:spcAft>
+                <a:spcPts val="0"/>
+              </a:spcAft>
+              <a:buNone/>
+            </a:pPr>
+            <a:r>
+              <a:rPr lang="en-US" sz="1000" i="1" dirty="0">
+                <a:solidFill>
+                  <a:srgbClr val="33424D"/>
+                </a:solidFill>
+                <a:latin typeface="Inter"/>
+                <a:ea typeface="Inter"/>
+                <a:cs typeface="Inter"/>
+              </a:rPr>
+              <a:t>What does human-centered mean here, and which real need does each AI use serve?</a:t>
+            </a:r>
+          </a:p>
+        </p:txBody>
+      </p:sp>
+      <p:sp>
+        <p:nvSpPr>
+          <p:cNvPr id="304" name="Shape 304"/>
+          <p:cNvSpPr/>
+          <p:nvPr/>
+        </p:nvSpPr>
+        <p:spPr>
+          <a:xfrm>
+            <a:off x="1005840" y="3737520"/>
+            <a:ext cx="2091690" cy="680000"/>
+          </a:xfrm>
+          <a:prstGeom prst="rect">
+            <a:avLst/>
+          </a:prstGeom>
+          <a:noFill/>
+          <a:ln>
+            <a:noFill/>
+          </a:ln>
+        </p:spPr>
+        <p:txBody>
+          <a:bodyPr wrap="square" lIns="0" tIns="0" rIns="0" bIns="0" anchor="t"/>
+          <a:lstStyle/>
+          <a:p>
+            <a:pPr marL="0" indent="0" algn="l">
+              <a:spcAft>
+                <a:spcPts val="200"/>
+              </a:spcAft>
+              <a:buNone/>
+            </a:pPr>
+            <a:r>
+              <a:rPr lang="en-US" sz="1100" b="1" dirty="0">
+                <a:solidFill>
+                  <a:srgbClr val="14202B"/>
+                </a:solidFill>
+                <a:latin typeface="Inter"/>
+                <a:ea typeface="Inter"/>
+                <a:cs typeface="Inter"/>
+              </a:rPr>
+              <a:t>Human Agency</a:t>
+            </a:r>
+            <a:r>
+              <a:rPr lang="en-US" sz="750" b="0" dirty="0">
+                <a:solidFill>
+                  <a:srgbClr val="5F6F7A"/>
+                </a:solidFill>
+                <a:latin typeface="Inter"/>
+                <a:ea typeface="Inter"/>
+                <a:cs typeface="Inter"/>
+              </a:rPr>
+              <a:t>  T·K</a:t>
+            </a:r>
+          </a:p>
+          <a:p>
+            <a:pPr marL="0" indent="0" algn="l">
+              <a:spcAft>
+                <a:spcPts val="0"/>
+              </a:spcAft>
+              <a:buNone/>
+            </a:pPr>
+            <a:r>
+              <a:rPr lang="en-US" sz="1000" i="1" dirty="0">
+                <a:solidFill>
+                  <a:srgbClr val="33424D"/>
+                </a:solidFill>
+                <a:latin typeface="Inter"/>
+                <a:ea typeface="Inter"/>
+                <a:cs typeface="Inter"/>
+              </a:rPr>
+              <a:t>Who decides, how far may AI agents act alone, and who answers for the result?</a:t>
+            </a:r>
+          </a:p>
+        </p:txBody>
+      </p:sp>
+      <p:sp>
+        <p:nvSpPr>
+          <p:cNvPr id="305" name="Shape 305"/>
+          <p:cNvSpPr/>
+          <p:nvPr/>
+        </p:nvSpPr>
+        <p:spPr>
+          <a:xfrm>
+            <a:off x="1005840" y="4457520"/>
+            <a:ext cx="2091690" cy="680000"/>
+          </a:xfrm>
+          <a:prstGeom prst="rect">
+            <a:avLst/>
+          </a:prstGeom>
+          <a:noFill/>
+          <a:ln>
+            <a:noFill/>
+          </a:ln>
+        </p:spPr>
+        <p:txBody>
+          <a:bodyPr wrap="square" lIns="0" tIns="0" rIns="0" bIns="0" anchor="t"/>
+          <a:lstStyle/>
+          <a:p>
+            <a:pPr marL="0" indent="0" algn="l">
+              <a:spcAft>
+                <a:spcPts val="200"/>
+              </a:spcAft>
+              <a:buNone/>
+            </a:pPr>
+            <a:r>
+              <a:rPr lang="en-US" sz="1100" b="1" dirty="0">
+                <a:solidFill>
+                  <a:srgbClr val="14202B"/>
+                </a:solidFill>
+                <a:latin typeface="Inter"/>
+                <a:ea typeface="Inter"/>
+                <a:cs typeface="Inter"/>
+              </a:rPr>
+              <a:t>Governance &amp; Ethics</a:t>
+            </a:r>
+            <a:r>
+              <a:rPr lang="en-US" sz="750" b="0" dirty="0">
+                <a:solidFill>
+                  <a:srgbClr val="5F6F7A"/>
+                </a:solidFill>
+                <a:latin typeface="Inter"/>
+                <a:ea typeface="Inter"/>
+                <a:cs typeface="Inter"/>
+              </a:rPr>
+              <a:t>  T·K</a:t>
+            </a:r>
+          </a:p>
+          <a:p>
+            <a:pPr marL="0" indent="0" algn="l">
+              <a:spcAft>
+                <a:spcPts val="0"/>
+              </a:spcAft>
+              <a:buNone/>
+            </a:pPr>
+            <a:r>
+              <a:rPr lang="en-US" sz="1000" i="1" dirty="0">
+                <a:solidFill>
+                  <a:srgbClr val="33424D"/>
+                </a:solidFill>
+                <a:latin typeface="Inter"/>
+                <a:ea typeface="Inter"/>
+                <a:cs typeface="Inter"/>
+              </a:rPr>
+              <a:t>Which rules, roles and enforcement turn our principles into daily practice?</a:t>
+            </a:r>
+          </a:p>
+        </p:txBody>
+      </p:sp>
+      <p:sp>
+        <p:nvSpPr>
+          <p:cNvPr id="306" name="Shape 306"/>
+          <p:cNvSpPr/>
+          <p:nvPr/>
+        </p:nvSpPr>
+        <p:spPr>
+          <a:xfrm>
+            <a:off x="1005840" y="5177520"/>
+            <a:ext cx="2091690" cy="680000"/>
+          </a:xfrm>
+          <a:prstGeom prst="rect">
+            <a:avLst/>
+          </a:prstGeom>
+          <a:noFill/>
+          <a:ln>
+            <a:noFill/>
+          </a:ln>
+        </p:spPr>
+        <p:txBody>
+          <a:bodyPr wrap="square" lIns="0" tIns="0" rIns="0" bIns="0" anchor="t"/>
+          <a:lstStyle/>
+          <a:p>
+            <a:pPr marL="0" indent="0" algn="l">
+              <a:spcAft>
+                <a:spcPts val="200"/>
+              </a:spcAft>
+              <a:buNone/>
+            </a:pPr>
+            <a:r>
+              <a:rPr lang="en-US" sz="1100" b="1" dirty="0">
+                <a:solidFill>
+                  <a:srgbClr val="14202B"/>
+                </a:solidFill>
+                <a:latin typeface="Inter"/>
+                <a:ea typeface="Inter"/>
+                <a:cs typeface="Inter"/>
+              </a:rPr>
+              <a:t>Review &amp; Adaptation</a:t>
+            </a:r>
+            <a:r>
+              <a:rPr lang="en-US" sz="750" b="0" dirty="0">
+                <a:solidFill>
+                  <a:srgbClr val="5F6F7A"/>
+                </a:solidFill>
+                <a:latin typeface="Inter"/>
+                <a:ea typeface="Inter"/>
+                <a:cs typeface="Inter"/>
+              </a:rPr>
+              <a:t>  T·K</a:t>
+            </a:r>
+          </a:p>
+          <a:p>
+            <a:pPr marL="0" indent="0" algn="l">
+              <a:spcAft>
+                <a:spcPts val="0"/>
+              </a:spcAft>
+              <a:buNone/>
+            </a:pPr>
+            <a:r>
+              <a:rPr lang="en-US" sz="1000" i="1" dirty="0">
+                <a:solidFill>
+                  <a:srgbClr val="33424D"/>
+                </a:solidFill>
+                <a:latin typeface="Inter"/>
+                <a:ea typeface="Inter"/>
+                <a:cs typeface="Inter"/>
+              </a:rPr>
+              <a:t>How do we track outcomes, harms and wellbeing, and adapt at a human pace?</a:t>
+            </a:r>
+          </a:p>
+        </p:txBody>
+      </p:sp>
+      <p:sp>
+        <p:nvSpPr>
+          <p:cNvPr id="307" name="Shape 307"/>
+          <p:cNvSpPr/>
+          <p:nvPr/>
+        </p:nvSpPr>
+        <p:spPr>
+          <a:xfrm>
+            <a:off x="3509010" y="2377440"/>
+            <a:ext cx="2457450" cy="3794760"/>
+          </a:xfrm>
+          <a:prstGeom prst="roundRect">
+            <a:avLst>
+              <a:gd name="adj" fmla="val 4000"/>
+            </a:avLst>
+          </a:prstGeom>
+          <a:solidFill>
+            <a:srgbClr val="FFFFFF"/>
+          </a:solidFill>
+          <a:ln w="12700">
+            <a:solidFill>
+              <a:srgbClr val="DCE8E5"/>
+            </a:solidFill>
+          </a:ln>
+        </p:spPr>
+        <p:txBody>
+          <a:bodyPr wrap="square" lIns="0" tIns="0" rIns="0" bIns="0" anchor="t"/>
+          <a:lstStyle/>
+          <a:p>
+            <a:endParaRPr lang="en-US"/>
+          </a:p>
+        </p:txBody>
+      </p:sp>
+      <p:sp>
+        <p:nvSpPr>
+          <p:cNvPr id="308" name="Shape 308"/>
+          <p:cNvSpPr/>
+          <p:nvPr/>
+        </p:nvSpPr>
+        <p:spPr>
+          <a:xfrm>
+            <a:off x="3646170" y="2542032"/>
+            <a:ext cx="2183130" cy="320040"/>
+          </a:xfrm>
+          <a:prstGeom prst="roundRect">
+            <a:avLst>
+              <a:gd name="adj" fmla="val 50000"/>
+            </a:avLst>
+          </a:prstGeom>
+          <a:solidFill>
+            <a:srgbClr val="E8EBF8"/>
+          </a:solidFill>
+          <a:ln w="12700">
+            <a:solidFill>
+              <a:srgbClr val="C6CDEE"/>
+            </a:solidFill>
+          </a:ln>
+        </p:spPr>
+        <p:txBody>
+          <a:bodyPr wrap="square" lIns="0" tIns="0" rIns="0" bIns="0" anchor="ctr"/>
+          <a:lstStyle/>
+          <a:p>
+            <a:pPr marL="0" indent="0" algn="ctr">
+              <a:spcAft>
+                <a:spcPts val="0"/>
+              </a:spcAft>
+              <a:buNone/>
+            </a:pPr>
+            <a:r>
+              <a:rPr lang="en-US" sz="900" b="1" spc="80" dirty="0">
+                <a:solidFill>
+                  <a:srgbClr val="2B3F9E"/>
+                </a:solidFill>
+                <a:latin typeface="IBM Plex Mono"/>
+                <a:ea typeface="IBM Plex Mono"/>
+                <a:cs typeface="IBM Plex Mono"/>
+              </a:rPr>
+              <a:t>PEOPLE &amp; WORK</a:t>
+            </a:r>
+          </a:p>
+        </p:txBody>
+      </p:sp>
+      <p:sp>
+        <p:nvSpPr>
+          <p:cNvPr id="309" name="Shape 309"/>
+          <p:cNvSpPr/>
+          <p:nvPr/>
+        </p:nvSpPr>
+        <p:spPr>
+          <a:xfrm>
+            <a:off x="3691890" y="3017520"/>
+            <a:ext cx="2091690" cy="680000"/>
+          </a:xfrm>
+          <a:prstGeom prst="rect">
+            <a:avLst/>
+          </a:prstGeom>
+          <a:noFill/>
+          <a:ln>
+            <a:noFill/>
+          </a:ln>
+        </p:spPr>
+        <p:txBody>
+          <a:bodyPr wrap="square" lIns="0" tIns="0" rIns="0" bIns="0" anchor="t"/>
+          <a:lstStyle/>
+          <a:p>
+            <a:pPr marL="0" indent="0" algn="l">
+              <a:spcAft>
+                <a:spcPts val="200"/>
+              </a:spcAft>
+              <a:buNone/>
+            </a:pPr>
+            <a:r>
+              <a:rPr lang="en-US" sz="1100" b="1" dirty="0">
+                <a:solidFill>
+                  <a:srgbClr val="14202B"/>
+                </a:solidFill>
+                <a:latin typeface="Inter"/>
+                <a:ea typeface="Inter"/>
+                <a:cs typeface="Inter"/>
+              </a:rPr>
+              <a:t>Meaningful Work</a:t>
+            </a:r>
+            <a:r>
+              <a:rPr lang="en-US" sz="750" b="0" dirty="0">
+                <a:solidFill>
+                  <a:srgbClr val="5F6F7A"/>
+                </a:solidFill>
+                <a:latin typeface="Inter"/>
+                <a:ea typeface="Inter"/>
+                <a:cs typeface="Inter"/>
+              </a:rPr>
+              <a:t>  K</a:t>
+            </a:r>
+          </a:p>
+          <a:p>
+            <a:pPr marL="0" indent="0" algn="l">
+              <a:spcAft>
+                <a:spcPts val="0"/>
+              </a:spcAft>
+              <a:buNone/>
+            </a:pPr>
+            <a:r>
+              <a:rPr lang="en-US" sz="1000" i="1" dirty="0">
+                <a:solidFill>
+                  <a:srgbClr val="33424D"/>
+                </a:solidFill>
+                <a:latin typeface="Inter"/>
+                <a:ea typeface="Inter"/>
+                <a:cs typeface="Inter"/>
+              </a:rPr>
+              <a:t>Which tasks must stay human to keep work competent and meaningful?</a:t>
+            </a:r>
+          </a:p>
+        </p:txBody>
+      </p:sp>
+      <p:sp>
+        <p:nvSpPr>
+          <p:cNvPr id="310" name="Shape 310"/>
+          <p:cNvSpPr/>
+          <p:nvPr/>
+        </p:nvSpPr>
+        <p:spPr>
+          <a:xfrm>
+            <a:off x="3691890" y="3737520"/>
+            <a:ext cx="2091690" cy="680000"/>
+          </a:xfrm>
+          <a:prstGeom prst="rect">
+            <a:avLst/>
+          </a:prstGeom>
+          <a:noFill/>
+          <a:ln>
+            <a:noFill/>
+          </a:ln>
+        </p:spPr>
+        <p:txBody>
+          <a:bodyPr wrap="square" lIns="0" tIns="0" rIns="0" bIns="0" anchor="t"/>
+          <a:lstStyle/>
+          <a:p>
+            <a:pPr marL="0" indent="0" algn="l">
+              <a:spcAft>
+                <a:spcPts val="200"/>
+              </a:spcAft>
+              <a:buNone/>
+            </a:pPr>
+            <a:r>
+              <a:rPr lang="en-US" sz="1100" b="1" dirty="0">
+                <a:solidFill>
+                  <a:srgbClr val="14202B"/>
+                </a:solidFill>
+                <a:latin typeface="Inter"/>
+                <a:ea typeface="Inter"/>
+                <a:cs typeface="Inter"/>
+              </a:rPr>
+              <a:t>Work Design</a:t>
+            </a:r>
+            <a:r>
+              <a:rPr lang="en-US" sz="750" b="0" dirty="0">
+                <a:solidFill>
+                  <a:srgbClr val="5F6F7A"/>
+                </a:solidFill>
+                <a:latin typeface="Inter"/>
+                <a:ea typeface="Inter"/>
+                <a:cs typeface="Inter"/>
+              </a:rPr>
+              <a:t>  T·K</a:t>
+            </a:r>
+          </a:p>
+          <a:p>
+            <a:pPr marL="0" indent="0" algn="l">
+              <a:spcAft>
+                <a:spcPts val="0"/>
+              </a:spcAft>
+              <a:buNone/>
+            </a:pPr>
+            <a:r>
+              <a:rPr lang="en-US" sz="1000" i="1" dirty="0">
+                <a:solidFill>
+                  <a:srgbClr val="33424D"/>
+                </a:solidFill>
+                <a:latin typeface="Inter"/>
+                <a:ea typeface="Inter"/>
+                <a:cs typeface="Inter"/>
+              </a:rPr>
+              <a:t>How do we split tasks between people and AI and redesign workflows?</a:t>
+            </a:r>
+          </a:p>
+        </p:txBody>
+      </p:sp>
+      <p:sp>
+        <p:nvSpPr>
+          <p:cNvPr id="311" name="Shape 311"/>
+          <p:cNvSpPr/>
+          <p:nvPr/>
+        </p:nvSpPr>
+        <p:spPr>
+          <a:xfrm>
+            <a:off x="3691890" y="4457520"/>
+            <a:ext cx="2091690" cy="680000"/>
+          </a:xfrm>
+          <a:prstGeom prst="rect">
+            <a:avLst/>
+          </a:prstGeom>
+          <a:noFill/>
+          <a:ln>
+            <a:noFill/>
+          </a:ln>
+        </p:spPr>
+        <p:txBody>
+          <a:bodyPr wrap="square" lIns="0" tIns="0" rIns="0" bIns="0" anchor="t"/>
+          <a:lstStyle/>
+          <a:p>
+            <a:pPr marL="0" indent="0" algn="l">
+              <a:spcAft>
+                <a:spcPts val="200"/>
+              </a:spcAft>
+              <a:buNone/>
+            </a:pPr>
+            <a:r>
+              <a:rPr lang="en-US" sz="1100" b="1" dirty="0">
+                <a:solidFill>
+                  <a:srgbClr val="14202B"/>
+                </a:solidFill>
+                <a:latin typeface="Inter"/>
+                <a:ea typeface="Inter"/>
+                <a:cs typeface="Inter"/>
+              </a:rPr>
+              <a:t>Workforce &amp; Learning</a:t>
+            </a:r>
+            <a:r>
+              <a:rPr lang="en-US" sz="750" b="0" dirty="0">
+                <a:solidFill>
+                  <a:srgbClr val="5F6F7A"/>
+                </a:solidFill>
+                <a:latin typeface="Inter"/>
+                <a:ea typeface="Inter"/>
+                <a:cs typeface="Inter"/>
+              </a:rPr>
+              <a:t>  T·K</a:t>
+            </a:r>
+          </a:p>
+          <a:p>
+            <a:pPr marL="0" indent="0" algn="l">
+              <a:spcAft>
+                <a:spcPts val="0"/>
+              </a:spcAft>
+              <a:buNone/>
+            </a:pPr>
+            <a:r>
+              <a:rPr lang="en-US" sz="1000" i="1" dirty="0">
+                <a:solidFill>
+                  <a:srgbClr val="33424D"/>
+                </a:solidFill>
+                <a:latin typeface="Inter"/>
+                <a:ea typeface="Inter"/>
+                <a:cs typeface="Inter"/>
+              </a:rPr>
+              <a:t>Which skills must people build or keep to use, verify and question AI?</a:t>
+            </a:r>
+          </a:p>
+        </p:txBody>
+      </p:sp>
+      <p:sp>
+        <p:nvSpPr>
+          <p:cNvPr id="312" name="Shape 312"/>
+          <p:cNvSpPr/>
+          <p:nvPr/>
+        </p:nvSpPr>
+        <p:spPr>
+          <a:xfrm>
+            <a:off x="3691890" y="5177520"/>
+            <a:ext cx="2091690" cy="680000"/>
+          </a:xfrm>
+          <a:prstGeom prst="rect">
+            <a:avLst/>
+          </a:prstGeom>
+          <a:noFill/>
+          <a:ln>
+            <a:noFill/>
+          </a:ln>
+        </p:spPr>
+        <p:txBody>
+          <a:bodyPr wrap="square" lIns="0" tIns="0" rIns="0" bIns="0" anchor="t"/>
+          <a:lstStyle/>
+          <a:p>
+            <a:pPr marL="0" indent="0" algn="l">
+              <a:spcAft>
+                <a:spcPts val="200"/>
+              </a:spcAft>
+              <a:buNone/>
+            </a:pPr>
+            <a:r>
+              <a:rPr lang="en-US" sz="1100" b="1" dirty="0">
+                <a:solidFill>
+                  <a:srgbClr val="14202B"/>
+                </a:solidFill>
+                <a:latin typeface="Inter"/>
+                <a:ea typeface="Inter"/>
+                <a:cs typeface="Inter"/>
+              </a:rPr>
+              <a:t>Quality &amp; Oversight</a:t>
+            </a:r>
+            <a:r>
+              <a:rPr lang="en-US" sz="750" b="0" dirty="0">
+                <a:solidFill>
+                  <a:srgbClr val="5F6F7A"/>
+                </a:solidFill>
+                <a:latin typeface="Inter"/>
+                <a:ea typeface="Inter"/>
+                <a:cs typeface="Inter"/>
+              </a:rPr>
+              <a:t>  T·K</a:t>
+            </a:r>
+          </a:p>
+          <a:p>
+            <a:pPr marL="0" indent="0" algn="l">
+              <a:spcAft>
+                <a:spcPts val="0"/>
+              </a:spcAft>
+              <a:buNone/>
+            </a:pPr>
+            <a:r>
+              <a:rPr lang="en-US" sz="1000" i="1" dirty="0">
+                <a:solidFill>
+                  <a:srgbClr val="33424D"/>
+                </a:solidFill>
+                <a:latin typeface="Inter"/>
+                <a:ea typeface="Inter"/>
+                <a:cs typeface="Inter"/>
+              </a:rPr>
+              <a:t>How do we verify AI output, surface uncertainty and prevent over-reliance?</a:t>
+            </a:r>
+          </a:p>
+        </p:txBody>
+      </p:sp>
+      <p:sp>
+        <p:nvSpPr>
+          <p:cNvPr id="313" name="Shape 313"/>
+          <p:cNvSpPr/>
+          <p:nvPr/>
+        </p:nvSpPr>
+        <p:spPr>
+          <a:xfrm>
+            <a:off x="6195060" y="2377440"/>
+            <a:ext cx="2457450" cy="3794760"/>
+          </a:xfrm>
+          <a:prstGeom prst="roundRect">
+            <a:avLst>
+              <a:gd name="adj" fmla="val 4000"/>
+            </a:avLst>
+          </a:prstGeom>
+          <a:solidFill>
+            <a:srgbClr val="FFFFFF"/>
+          </a:solidFill>
+          <a:ln w="12700">
+            <a:solidFill>
+              <a:srgbClr val="DCE8E5"/>
+            </a:solidFill>
+          </a:ln>
+        </p:spPr>
+        <p:txBody>
+          <a:bodyPr wrap="square" lIns="0" tIns="0" rIns="0" bIns="0" anchor="t"/>
+          <a:lstStyle/>
+          <a:p>
+            <a:endParaRPr lang="en-US"/>
+          </a:p>
+        </p:txBody>
+      </p:sp>
+      <p:sp>
+        <p:nvSpPr>
+          <p:cNvPr id="314" name="Shape 314"/>
+          <p:cNvSpPr/>
+          <p:nvPr/>
+        </p:nvSpPr>
+        <p:spPr>
+          <a:xfrm>
+            <a:off x="6332220" y="2542032"/>
+            <a:ext cx="2183130" cy="320040"/>
+          </a:xfrm>
+          <a:prstGeom prst="roundRect">
+            <a:avLst>
+              <a:gd name="adj" fmla="val 50000"/>
+            </a:avLst>
+          </a:prstGeom>
+          <a:solidFill>
+            <a:srgbClr val="FEF3DD"/>
+          </a:solidFill>
+          <a:ln w="12700">
+            <a:solidFill>
+              <a:srgbClr val="F3DDA8"/>
+            </a:solidFill>
+          </a:ln>
+        </p:spPr>
+        <p:txBody>
+          <a:bodyPr wrap="square" lIns="0" tIns="0" rIns="0" bIns="0" anchor="ctr"/>
+          <a:lstStyle/>
+          <a:p>
+            <a:pPr marL="0" indent="0" algn="ctr">
+              <a:spcAft>
+                <a:spcPts val="0"/>
+              </a:spcAft>
+              <a:buNone/>
+            </a:pPr>
+            <a:r>
+              <a:rPr lang="en-US" sz="900" b="1" spc="80" dirty="0">
+                <a:solidFill>
+                  <a:srgbClr val="8A5A00"/>
+                </a:solidFill>
+                <a:latin typeface="IBM Plex Mono"/>
+                <a:ea typeface="IBM Plex Mono"/>
+                <a:cs typeface="IBM Plex Mono"/>
+              </a:rPr>
+              <a:t>CULTURE &amp; VOICE</a:t>
+            </a:r>
+          </a:p>
+        </p:txBody>
+      </p:sp>
+      <p:sp>
+        <p:nvSpPr>
+          <p:cNvPr id="315" name="Shape 315"/>
+          <p:cNvSpPr/>
+          <p:nvPr/>
+        </p:nvSpPr>
+        <p:spPr>
+          <a:xfrm>
+            <a:off x="6377940" y="3017520"/>
+            <a:ext cx="2091690" cy="680000"/>
+          </a:xfrm>
+          <a:prstGeom prst="rect">
+            <a:avLst/>
+          </a:prstGeom>
+          <a:noFill/>
+          <a:ln>
+            <a:noFill/>
+          </a:ln>
+        </p:spPr>
+        <p:txBody>
+          <a:bodyPr wrap="square" lIns="0" tIns="0" rIns="0" bIns="0" anchor="t"/>
+          <a:lstStyle/>
+          <a:p>
+            <a:pPr marL="0" indent="0" algn="l">
+              <a:spcAft>
+                <a:spcPts val="200"/>
+              </a:spcAft>
+              <a:buNone/>
+            </a:pPr>
+            <a:r>
+              <a:rPr lang="en-US" sz="1100" b="1" dirty="0">
+                <a:solidFill>
+                  <a:srgbClr val="14202B"/>
+                </a:solidFill>
+                <a:latin typeface="Inter"/>
+                <a:ea typeface="Inter"/>
+                <a:cs typeface="Inter"/>
+              </a:rPr>
+              <a:t>Communication</a:t>
+            </a:r>
+            <a:r>
+              <a:rPr lang="en-US" sz="750" b="0" dirty="0">
+                <a:solidFill>
+                  <a:srgbClr val="5F6F7A"/>
+                </a:solidFill>
+                <a:latin typeface="Inter"/>
+                <a:ea typeface="Inter"/>
+                <a:cs typeface="Inter"/>
+              </a:rPr>
+              <a:t>  T·K</a:t>
+            </a:r>
+          </a:p>
+          <a:p>
+            <a:pPr marL="0" indent="0" algn="l">
+              <a:spcAft>
+                <a:spcPts val="0"/>
+              </a:spcAft>
+              <a:buNone/>
+            </a:pPr>
+            <a:r>
+              <a:rPr lang="en-US" sz="1000" i="1" dirty="0">
+                <a:solidFill>
+                  <a:srgbClr val="33424D"/>
+                </a:solidFill>
+                <a:latin typeface="Inter"/>
+                <a:ea typeface="Inter"/>
+                <a:cs typeface="Inter"/>
+              </a:rPr>
+              <a:t>Do people know where, how and why AI is used, and how their data is handled?</a:t>
+            </a:r>
+          </a:p>
+        </p:txBody>
+      </p:sp>
+      <p:sp>
+        <p:nvSpPr>
+          <p:cNvPr id="316" name="Shape 316"/>
+          <p:cNvSpPr/>
+          <p:nvPr/>
+        </p:nvSpPr>
+        <p:spPr>
+          <a:xfrm>
+            <a:off x="6377940" y="3737520"/>
+            <a:ext cx="2091690" cy="680000"/>
+          </a:xfrm>
+          <a:prstGeom prst="rect">
+            <a:avLst/>
+          </a:prstGeom>
+          <a:noFill/>
+          <a:ln>
+            <a:noFill/>
+          </a:ln>
+        </p:spPr>
+        <p:txBody>
+          <a:bodyPr wrap="square" lIns="0" tIns="0" rIns="0" bIns="0" anchor="t"/>
+          <a:lstStyle/>
+          <a:p>
+            <a:pPr marL="0" indent="0" algn="l">
+              <a:spcAft>
+                <a:spcPts val="200"/>
+              </a:spcAft>
+              <a:buNone/>
+            </a:pPr>
+            <a:r>
+              <a:rPr lang="en-US" sz="1100" b="1" dirty="0">
+                <a:solidFill>
+                  <a:srgbClr val="14202B"/>
+                </a:solidFill>
+                <a:latin typeface="Inter"/>
+                <a:ea typeface="Inter"/>
+                <a:cs typeface="Inter"/>
+              </a:rPr>
+              <a:t>Participation</a:t>
+            </a:r>
+            <a:r>
+              <a:rPr lang="en-US" sz="750" b="0" dirty="0">
+                <a:solidFill>
+                  <a:srgbClr val="5F6F7A"/>
+                </a:solidFill>
+                <a:latin typeface="Inter"/>
+                <a:ea typeface="Inter"/>
+                <a:cs typeface="Inter"/>
+              </a:rPr>
+              <a:t>  T·K</a:t>
+            </a:r>
+          </a:p>
+          <a:p>
+            <a:pPr marL="0" indent="0" algn="l">
+              <a:spcAft>
+                <a:spcPts val="0"/>
+              </a:spcAft>
+              <a:buNone/>
+            </a:pPr>
+            <a:r>
+              <a:rPr lang="en-US" sz="1000" i="1" dirty="0">
+                <a:solidFill>
+                  <a:srgbClr val="33424D"/>
+                </a:solidFill>
+                <a:latin typeface="Inter"/>
+                <a:ea typeface="Inter"/>
+                <a:cs typeface="Inter"/>
+              </a:rPr>
+              <a:t>How do employees and their representatives co-design and contest AI use?</a:t>
+            </a:r>
+          </a:p>
+        </p:txBody>
+      </p:sp>
+      <p:sp>
+        <p:nvSpPr>
+          <p:cNvPr id="317" name="Shape 317"/>
+          <p:cNvSpPr/>
+          <p:nvPr/>
+        </p:nvSpPr>
+        <p:spPr>
+          <a:xfrm>
+            <a:off x="6377940" y="4457520"/>
+            <a:ext cx="2091690" cy="680000"/>
+          </a:xfrm>
+          <a:prstGeom prst="rect">
+            <a:avLst/>
+          </a:prstGeom>
+          <a:noFill/>
+          <a:ln>
+            <a:noFill/>
+          </a:ln>
+        </p:spPr>
+        <p:txBody>
+          <a:bodyPr wrap="square" lIns="0" tIns="0" rIns="0" bIns="0" anchor="t"/>
+          <a:lstStyle/>
+          <a:p>
+            <a:pPr marL="0" indent="0" algn="l">
+              <a:spcAft>
+                <a:spcPts val="200"/>
+              </a:spcAft>
+              <a:buNone/>
+            </a:pPr>
+            <a:r>
+              <a:rPr lang="en-US" sz="1100" b="1" dirty="0">
+                <a:solidFill>
+                  <a:srgbClr val="14202B"/>
+                </a:solidFill>
+                <a:latin typeface="Inter"/>
+                <a:ea typeface="Inter"/>
+                <a:cs typeface="Inter"/>
+              </a:rPr>
+              <a:t>Questioning Culture</a:t>
+            </a:r>
+            <a:r>
+              <a:rPr lang="en-US" sz="750" b="0" dirty="0">
+                <a:solidFill>
+                  <a:srgbClr val="5F6F7A"/>
+                </a:solidFill>
+                <a:latin typeface="Inter"/>
+                <a:ea typeface="Inter"/>
+                <a:cs typeface="Inter"/>
+              </a:rPr>
+              <a:t>  T·K</a:t>
+            </a:r>
+          </a:p>
+          <a:p>
+            <a:pPr marL="0" indent="0" algn="l">
+              <a:spcAft>
+                <a:spcPts val="0"/>
+              </a:spcAft>
+              <a:buNone/>
+            </a:pPr>
+            <a:r>
+              <a:rPr lang="en-US" sz="1000" i="1" dirty="0">
+                <a:solidFill>
+                  <a:srgbClr val="33424D"/>
+                </a:solidFill>
+                <a:latin typeface="Inter"/>
+                <a:ea typeface="Inter"/>
+                <a:cs typeface="Inter"/>
+              </a:rPr>
+              <a:t>Can people experiment, make mistakes and reject AI output without pressure?</a:t>
+            </a:r>
+          </a:p>
+        </p:txBody>
+      </p:sp>
+      <p:sp>
+        <p:nvSpPr>
+          <p:cNvPr id="318" name="Shape 318"/>
+          <p:cNvSpPr/>
+          <p:nvPr/>
+        </p:nvSpPr>
+        <p:spPr>
+          <a:xfrm>
+            <a:off x="6377940" y="5177520"/>
+            <a:ext cx="2091690" cy="680000"/>
+          </a:xfrm>
+          <a:prstGeom prst="rect">
+            <a:avLst/>
+          </a:prstGeom>
+          <a:noFill/>
+          <a:ln>
+            <a:noFill/>
+          </a:ln>
+        </p:spPr>
+        <p:txBody>
+          <a:bodyPr wrap="square" lIns="0" tIns="0" rIns="0" bIns="0" anchor="t"/>
+          <a:lstStyle/>
+          <a:p>
+            <a:pPr marL="0" indent="0" algn="l">
+              <a:spcAft>
+                <a:spcPts val="200"/>
+              </a:spcAft>
+              <a:buNone/>
+            </a:pPr>
+            <a:r>
+              <a:rPr lang="en-US" sz="1100" b="1" dirty="0">
+                <a:solidFill>
+                  <a:srgbClr val="14202B"/>
+                </a:solidFill>
+                <a:latin typeface="Inter"/>
+                <a:ea typeface="Inter"/>
+                <a:cs typeface="Inter"/>
+              </a:rPr>
+              <a:t>Power &amp; Dynamics</a:t>
+            </a:r>
+            <a:r>
+              <a:rPr lang="en-US" sz="750" b="0" dirty="0">
+                <a:solidFill>
+                  <a:srgbClr val="5F6F7A"/>
+                </a:solidFill>
+                <a:latin typeface="Inter"/>
+                <a:ea typeface="Inter"/>
+                <a:cs typeface="Inter"/>
+              </a:rPr>
+              <a:t>  T</a:t>
+            </a:r>
+          </a:p>
+          <a:p>
+            <a:pPr marL="0" indent="0" algn="l">
+              <a:spcAft>
+                <a:spcPts val="0"/>
+              </a:spcAft>
+              <a:buNone/>
+            </a:pPr>
+            <a:r>
+              <a:rPr lang="en-US" sz="1000" i="1" dirty="0">
+                <a:solidFill>
+                  <a:srgbClr val="33424D"/>
+                </a:solidFill>
+                <a:latin typeface="Inter"/>
+                <a:ea typeface="Inter"/>
+                <a:cs typeface="Inter"/>
+              </a:rPr>
+              <a:t>Whose interests, roles and timing shape AI, and where does resistance come from?</a:t>
+            </a:r>
+          </a:p>
+        </p:txBody>
+      </p:sp>
+      <p:sp>
+        <p:nvSpPr>
+          <p:cNvPr id="319" name="Shape 319"/>
+          <p:cNvSpPr/>
+          <p:nvPr/>
+        </p:nvSpPr>
+        <p:spPr>
+          <a:xfrm>
+            <a:off x="8881110" y="2377440"/>
+            <a:ext cx="2457450" cy="3794760"/>
+          </a:xfrm>
+          <a:prstGeom prst="roundRect">
+            <a:avLst>
+              <a:gd name="adj" fmla="val 4000"/>
+            </a:avLst>
+          </a:prstGeom>
+          <a:solidFill>
+            <a:srgbClr val="FFFFFF"/>
+          </a:solidFill>
+          <a:ln w="12700">
+            <a:solidFill>
+              <a:srgbClr val="DCE8E5"/>
+            </a:solidFill>
+          </a:ln>
+        </p:spPr>
+        <p:txBody>
+          <a:bodyPr wrap="square" lIns="0" tIns="0" rIns="0" bIns="0" anchor="t"/>
+          <a:lstStyle/>
+          <a:p>
+            <a:endParaRPr lang="en-US"/>
+          </a:p>
+        </p:txBody>
+      </p:sp>
+      <p:sp>
+        <p:nvSpPr>
+          <p:cNvPr id="320" name="Shape 320"/>
+          <p:cNvSpPr/>
+          <p:nvPr/>
+        </p:nvSpPr>
+        <p:spPr>
+          <a:xfrm>
+            <a:off x="9018270" y="2542032"/>
+            <a:ext cx="2183130" cy="320040"/>
+          </a:xfrm>
+          <a:prstGeom prst="roundRect">
+            <a:avLst>
+              <a:gd name="adj" fmla="val 50000"/>
+            </a:avLst>
+          </a:prstGeom>
+          <a:solidFill>
+            <a:srgbClr val="EEF1F4"/>
+          </a:solidFill>
+          <a:ln w="12700">
+            <a:solidFill>
+              <a:srgbClr val="CDD5DC"/>
+            </a:solidFill>
+          </a:ln>
+        </p:spPr>
+        <p:txBody>
+          <a:bodyPr wrap="square" lIns="0" tIns="0" rIns="0" bIns="0" anchor="ctr"/>
+          <a:lstStyle/>
+          <a:p>
+            <a:pPr marL="0" indent="0" algn="ctr">
+              <a:spcAft>
+                <a:spcPts val="0"/>
+              </a:spcAft>
+              <a:buNone/>
+            </a:pPr>
+            <a:r>
+              <a:rPr lang="en-US" sz="900" b="1" spc="80" dirty="0">
+                <a:solidFill>
+                  <a:srgbClr val="33424D"/>
+                </a:solidFill>
+                <a:latin typeface="IBM Plex Mono"/>
+                <a:ea typeface="IBM Plex Mono"/>
+                <a:cs typeface="IBM Plex Mono"/>
+              </a:rPr>
+              <a:t>BOUNDARIES &amp; DUTIES</a:t>
+            </a:r>
+          </a:p>
+        </p:txBody>
+      </p:sp>
+      <p:sp>
+        <p:nvSpPr>
+          <p:cNvPr id="321" name="Shape 321"/>
+          <p:cNvSpPr/>
+          <p:nvPr/>
+        </p:nvSpPr>
+        <p:spPr>
+          <a:xfrm>
+            <a:off x="9063990" y="3017520"/>
+            <a:ext cx="2091690" cy="680000"/>
+          </a:xfrm>
+          <a:prstGeom prst="rect">
+            <a:avLst/>
+          </a:prstGeom>
+          <a:noFill/>
+          <a:ln>
+            <a:noFill/>
+          </a:ln>
+        </p:spPr>
+        <p:txBody>
+          <a:bodyPr wrap="square" lIns="0" tIns="0" rIns="0" bIns="0" anchor="t"/>
+          <a:lstStyle/>
+          <a:p>
+            <a:pPr marL="0" indent="0" algn="l">
+              <a:spcAft>
+                <a:spcPts val="200"/>
+              </a:spcAft>
+              <a:buNone/>
+            </a:pPr>
+            <a:r>
+              <a:rPr lang="en-US" sz="1100" b="1" dirty="0">
+                <a:solidFill>
+                  <a:srgbClr val="14202B"/>
+                </a:solidFill>
+                <a:latin typeface="Inter"/>
+                <a:ea typeface="Inter"/>
+                <a:cs typeface="Inter"/>
+              </a:rPr>
+              <a:t>Risk &amp; Boundaries</a:t>
+            </a:r>
+            <a:r>
+              <a:rPr lang="en-US" sz="750" b="0" dirty="0">
+                <a:solidFill>
+                  <a:srgbClr val="5F6F7A"/>
+                </a:solidFill>
+                <a:latin typeface="Inter"/>
+                <a:ea typeface="Inter"/>
+                <a:cs typeface="Inter"/>
+              </a:rPr>
+              <a:t>  T·K</a:t>
+            </a:r>
+          </a:p>
+          <a:p>
+            <a:pPr marL="0" indent="0" algn="l">
+              <a:spcAft>
+                <a:spcPts val="0"/>
+              </a:spcAft>
+              <a:buNone/>
+            </a:pPr>
+            <a:r>
+              <a:rPr lang="en-US" sz="1000" i="1" dirty="0">
+                <a:solidFill>
+                  <a:srgbClr val="33424D"/>
+                </a:solidFill>
+                <a:latin typeface="Inter"/>
+                <a:ea typeface="Inter"/>
+                <a:cs typeface="Inter"/>
+              </a:rPr>
+              <a:t>Where is AI restricted or off-limits, e.g. HR, health, monitoring of staff?</a:t>
+            </a:r>
+          </a:p>
+        </p:txBody>
+      </p:sp>
+      <p:sp>
+        <p:nvSpPr>
+          <p:cNvPr id="322" name="Shape 322"/>
+          <p:cNvSpPr/>
+          <p:nvPr/>
+        </p:nvSpPr>
+        <p:spPr>
+          <a:xfrm>
+            <a:off x="9063990" y="3737520"/>
+            <a:ext cx="2091690" cy="680000"/>
+          </a:xfrm>
+          <a:prstGeom prst="rect">
+            <a:avLst/>
+          </a:prstGeom>
+          <a:noFill/>
+          <a:ln>
+            <a:noFill/>
+          </a:ln>
+        </p:spPr>
+        <p:txBody>
+          <a:bodyPr wrap="square" lIns="0" tIns="0" rIns="0" bIns="0" anchor="t"/>
+          <a:lstStyle/>
+          <a:p>
+            <a:pPr marL="0" indent="0" algn="l">
+              <a:spcAft>
+                <a:spcPts val="200"/>
+              </a:spcAft>
+              <a:buNone/>
+            </a:pPr>
+            <a:r>
+              <a:rPr lang="en-US" sz="1100" b="1" dirty="0">
+                <a:solidFill>
+                  <a:srgbClr val="14202B"/>
+                </a:solidFill>
+                <a:latin typeface="Inter"/>
+                <a:ea typeface="Inter"/>
+                <a:cs typeface="Inter"/>
+              </a:rPr>
+              <a:t>Legal &amp; Compliance</a:t>
+            </a:r>
+            <a:r>
+              <a:rPr lang="en-US" sz="750" b="0" dirty="0">
+                <a:solidFill>
+                  <a:srgbClr val="5F6F7A"/>
+                </a:solidFill>
+                <a:latin typeface="Inter"/>
+                <a:ea typeface="Inter"/>
+                <a:cs typeface="Inter"/>
+              </a:rPr>
+              <a:t>  T·K</a:t>
+            </a:r>
+          </a:p>
+          <a:p>
+            <a:pPr marL="0" indent="0" algn="l">
+              <a:spcAft>
+                <a:spcPts val="0"/>
+              </a:spcAft>
+              <a:buNone/>
+            </a:pPr>
+            <a:r>
+              <a:rPr lang="en-US" sz="1000" i="1" dirty="0">
+                <a:solidFill>
+                  <a:srgbClr val="33424D"/>
+                </a:solidFill>
+                <a:latin typeface="Inter"/>
+                <a:ea typeface="Inter"/>
+                <a:cs typeface="Inter"/>
+              </a:rPr>
+              <a:t>Which laws and regulations, like the EU AI Act, apply to each AI use?</a:t>
+            </a:r>
+          </a:p>
+        </p:txBody>
+      </p:sp>
+      <p:sp>
+        <p:nvSpPr>
+          <p:cNvPr id="323" name="Shape 323"/>
+          <p:cNvSpPr/>
+          <p:nvPr/>
+        </p:nvSpPr>
+        <p:spPr>
+          <a:xfrm>
+            <a:off x="9063990" y="4457520"/>
+            <a:ext cx="2091690" cy="680000"/>
+          </a:xfrm>
+          <a:prstGeom prst="rect">
+            <a:avLst/>
+          </a:prstGeom>
+          <a:noFill/>
+          <a:ln>
+            <a:noFill/>
+          </a:ln>
+        </p:spPr>
+        <p:txBody>
+          <a:bodyPr wrap="square" lIns="0" tIns="0" rIns="0" bIns="0" anchor="t"/>
+          <a:lstStyle/>
+          <a:p>
+            <a:pPr marL="0" indent="0" algn="l">
+              <a:spcAft>
+                <a:spcPts val="200"/>
+              </a:spcAft>
+              <a:buNone/>
+            </a:pPr>
+            <a:r>
+              <a:rPr lang="en-US" sz="1100" b="1" dirty="0">
+                <a:solidFill>
+                  <a:srgbClr val="14202B"/>
+                </a:solidFill>
+                <a:latin typeface="Inter"/>
+                <a:ea typeface="Inter"/>
+                <a:cs typeface="Inter"/>
+              </a:rPr>
+              <a:t>IP &amp; Data Ownership</a:t>
+            </a:r>
+            <a:r>
+              <a:rPr lang="en-US" sz="750" b="0" dirty="0">
+                <a:solidFill>
+                  <a:srgbClr val="5F6F7A"/>
+                </a:solidFill>
+                <a:latin typeface="Inter"/>
+                <a:ea typeface="Inter"/>
+                <a:cs typeface="Inter"/>
+              </a:rPr>
+              <a:t>  T</a:t>
+            </a:r>
+          </a:p>
+          <a:p>
+            <a:pPr marL="0" indent="0" algn="l">
+              <a:spcAft>
+                <a:spcPts val="0"/>
+              </a:spcAft>
+              <a:buNone/>
+            </a:pPr>
+            <a:r>
+              <a:rPr lang="en-US" sz="1000" i="1" dirty="0">
+                <a:solidFill>
+                  <a:srgbClr val="33424D"/>
+                </a:solidFill>
+                <a:latin typeface="Inter"/>
+                <a:ea typeface="Inter"/>
+                <a:cs typeface="Inter"/>
+              </a:rPr>
+              <a:t>Who owns AI inputs, outputs and data, and what may leave the organization?</a:t>
+            </a:r>
+          </a:p>
+        </p:txBody>
+      </p:sp>
+      <p:sp>
+        <p:nvSpPr>
+          <p:cNvPr id="324" name="Shape 324"/>
+          <p:cNvSpPr/>
+          <p:nvPr/>
+        </p:nvSpPr>
+        <p:spPr>
+          <a:xfrm>
+            <a:off x="9063990" y="5177520"/>
+            <a:ext cx="2091690" cy="680000"/>
+          </a:xfrm>
+          <a:prstGeom prst="rect">
+            <a:avLst/>
+          </a:prstGeom>
+          <a:noFill/>
+          <a:ln>
+            <a:noFill/>
+          </a:ln>
+        </p:spPr>
+        <p:txBody>
+          <a:bodyPr wrap="square" lIns="0" tIns="0" rIns="0" bIns="0" anchor="t"/>
+          <a:lstStyle/>
+          <a:p>
+            <a:pPr marL="0" indent="0" algn="l">
+              <a:spcAft>
+                <a:spcPts val="200"/>
+              </a:spcAft>
+              <a:buNone/>
+            </a:pPr>
+            <a:r>
+              <a:rPr lang="en-US" sz="1100" b="1" dirty="0">
+                <a:solidFill>
+                  <a:srgbClr val="14202B"/>
+                </a:solidFill>
+                <a:latin typeface="Inter"/>
+                <a:ea typeface="Inter"/>
+                <a:cs typeface="Inter"/>
+              </a:rPr>
+              <a:t>Sustainability</a:t>
+            </a:r>
+            <a:r>
+              <a:rPr lang="en-US" sz="750" b="0" dirty="0">
+                <a:solidFill>
+                  <a:srgbClr val="5F6F7A"/>
+                </a:solidFill>
+                <a:latin typeface="Inter"/>
+                <a:ea typeface="Inter"/>
+                <a:cs typeface="Inter"/>
+              </a:rPr>
+              <a:t>  K</a:t>
+            </a:r>
+          </a:p>
+          <a:p>
+            <a:pPr marL="0" indent="0" algn="l">
+              <a:spcAft>
+                <a:spcPts val="0"/>
+              </a:spcAft>
+              <a:buNone/>
+            </a:pPr>
+            <a:r>
+              <a:rPr lang="en-US" sz="1000" i="1" dirty="0">
+                <a:solidFill>
+                  <a:srgbClr val="33424D"/>
+                </a:solidFill>
+                <a:latin typeface="Inter"/>
+                <a:ea typeface="Inter"/>
+                <a:cs typeface="Inter"/>
+              </a:rPr>
+              <a:t>What is the environmental and long-term societal cost of our AI use?</a:t>
+            </a:r>
+          </a:p>
+        </p:txBody>
+      </p:sp>
+      <p:sp>
+        <p:nvSpPr>
+          <p:cNvPr id="25" name="Text 18"/>
+          <p:cNvSpPr/>
+          <p:nvPr/>
+        </p:nvSpPr>
+        <p:spPr>
+          <a:xfrm>
+            <a:off x="822960" y="6419088"/>
+            <a:ext cx="4800000" cy="274320"/>
+          </a:xfrm>
+          <a:prstGeom prst="rect">
+            <a:avLst/>
+          </a:prstGeom>
+          <a:noFill/>
+          <a:ln/>
+        </p:spPr>
+        <p:txBody>
+          <a:bodyPr wrap="square" rtlCol="0" anchor="ctr"/>
+          <a:lstStyle/>
+          <a:p>
+            <a:pPr marL="0" indent="0" algn="l">
+              <a:buNone/>
+            </a:pPr>
+            <a:r>
+              <a:rPr lang="en-US" sz="900" dirty="0">
+                <a:solidFill>
+                  <a:srgbClr val="5B6B77"/>
+                </a:solidFill>
+                <a:latin typeface="Inter" pitchFamily="34" charset="0"/>
+                <a:ea typeface="Inter" pitchFamily="34" charset="-122"/>
+                <a:cs typeface="Inter" pitchFamily="34" charset="-120"/>
+              </a:rPr>
+              <a:t>Reflexive AI Research Initiative · Lucid Institute for Organizational Science</a:t>
+            </a:r>
+            <a:endParaRPr lang="en-US" sz="900" dirty="0"/>
+          </a:p>
+        </p:txBody>
+      </p:sp>
+      <p:sp>
+        <p:nvSpPr>
+          <p:cNvPr id="26" name="Source legend"/>
+          <p:cNvSpPr/>
+          <p:nvPr/>
+        </p:nvSpPr>
+        <p:spPr>
+          <a:xfrm>
+            <a:off x="5600000" y="6419088"/>
+            <a:ext cx="5738560" cy="274320"/>
+          </a:xfrm>
+          <a:prstGeom prst="rect">
+            <a:avLst/>
+          </a:prstGeom>
+          <a:noFill/>
+          <a:ln/>
+        </p:spPr>
+        <p:txBody>
+          <a:bodyPr wrap="square" rtlCol="0" anchor="ctr"/>
+          <a:lstStyle/>
+          <a:p>
+            <a:pPr marL="0" indent="0" algn="r">
+              <a:buNone/>
+            </a:pPr>
+            <a:r>
+              <a:rPr lang="en-US" sz="900" dirty="0">
+                <a:solidFill>
+                  <a:srgbClr val="5B6B77"/>
+                </a:solidFill>
+                <a:latin typeface="Inter" pitchFamily="34" charset="0"/>
+                <a:ea typeface="Inter" pitchFamily="34" charset="-122"/>
+                <a:cs typeface="Inter" pitchFamily="34" charset="-120"/>
+              </a:rPr>
+              <a:t>T = Literature Review by Tavantzis et al. (2027) · K = Expert interviews by Z. </a:t>
+            </a:r>
+            <a:r>
+              <a:rPr lang="en-US" sz="900" dirty="0" err="1">
+                <a:solidFill>
+                  <a:srgbClr val="5B6B77"/>
+                </a:solidFill>
+                <a:latin typeface="Inter" pitchFamily="34" charset="0"/>
+                <a:ea typeface="Inter" pitchFamily="34" charset="-122"/>
+                <a:cs typeface="Inter" pitchFamily="34" charset="-120"/>
+              </a:rPr>
+              <a:t>Kaskin</a:t>
+            </a:r>
+            <a:r>
+              <a:rPr lang="en-US" sz="900" dirty="0">
+                <a:solidFill>
+                  <a:srgbClr val="5B6B77"/>
+                </a:solidFill>
+                <a:latin typeface="Inter" pitchFamily="34" charset="0"/>
+                <a:ea typeface="Inter" pitchFamily="34" charset="-122"/>
+                <a:cs typeface="Inter" pitchFamily="34" charset="-120"/>
+              </a:rPr>
+              <a:t> (2026)</a:t>
+            </a:r>
+            <a:endParaRPr lang="en-US" sz="900" dirty="0"/>
+          </a:p>
+        </p:txBody>
+      </p:sp>
+    </p:spTree>
+  </p:cSld>
+  <p:clrMapOvr>
+    <a:masterClrMapping/>
+  </p:clrMapOvr>
+</p:sld>
+</file>
+
+<file path=ppt/slides/slide9.xml><?xml version="1.0" encoding="utf-8"?>
+<p:sld xmlns:a="http://schemas.openxmlformats.org/drawingml/2006/main" xmlns:r="http://schemas.openxmlformats.org/officeDocument/2006/relationships" xmlns:p="http://schemas.openxmlformats.org/presentationml/2006/main">
   <p:cSld name="Slide 6">
     <p:bg>
       <p:bgPr>
@@ -7003,261 +9554,6 @@
               <a:rPr lang="en-US" sz="900" dirty="0">
                 <a:solidFill>
                   <a:srgbClr val="5B6B77"/>
-                </a:solidFill>
-                <a:latin typeface="Inter" pitchFamily="34" charset="0"/>
-                <a:ea typeface="Inter" pitchFamily="34" charset="-122"/>
-                <a:cs typeface="Inter" pitchFamily="34" charset="-120"/>
-              </a:rPr>
-              <a:t>Reflexive AI Research Initiative · Lucid Institute for Organizational Science</a:t>
-            </a:r>
-            <a:endParaRPr lang="en-US" sz="900" dirty="0"/>
-          </a:p>
-        </p:txBody>
-      </p:sp>
-    </p:spTree>
-  </p:cSld>
-  <p:clrMapOvr>
-    <a:masterClrMapping/>
-  </p:clrMapOvr>
-</p:sld>
-</file>
-
-<file path=ppt/slides/slide9.xml><?xml version="1.0" encoding="utf-8"?>
-<p:sld xmlns:a="http://schemas.openxmlformats.org/drawingml/2006/main" xmlns:r="http://schemas.openxmlformats.org/officeDocument/2006/relationships" xmlns:p="http://schemas.openxmlformats.org/presentationml/2006/main">
-  <p:cSld name="Slide 7">
-    <p:bg>
-      <p:bgPr>
-        <a:solidFill>
-          <a:srgbClr val="0B444A"/>
-        </a:solidFill>
-        <a:effectLst/>
-      </p:bgPr>
-    </p:bg>
-    <p:spTree>
-      <p:nvGrpSpPr>
-        <p:cNvPr id="1" name=""/>
-        <p:cNvGrpSpPr/>
-        <p:nvPr/>
-      </p:nvGrpSpPr>
-      <p:grpSpPr>
-        <a:xfrm>
-          <a:off x="0" y="0"/>
-          <a:ext cx="0" cy="0"/>
-          <a:chOff x="0" y="0"/>
-          <a:chExt cx="0" cy="0"/>
-        </a:xfrm>
-      </p:grpSpPr>
-      <p:pic>
-        <p:nvPicPr>
-          <p:cNvPr id="2" name="Image 0" descr="preencoded.png"/>
-          <p:cNvPicPr>
-            <a:picLocks noChangeAspect="1"/>
-          </p:cNvPicPr>
-          <p:nvPr/>
-        </p:nvPicPr>
-        <p:blipFill>
-          <a:blip r:embed="rId3"/>
-          <a:stretch>
-            <a:fillRect/>
-          </a:stretch>
-        </p:blipFill>
-        <p:spPr>
-          <a:xfrm>
-            <a:off x="0" y="0"/>
-            <a:ext cx="12191695" cy="6858000"/>
-          </a:xfrm>
-          <a:prstGeom prst="rect">
-            <a:avLst/>
-          </a:prstGeom>
-        </p:spPr>
-      </p:pic>
-      <p:sp>
-        <p:nvSpPr>
-          <p:cNvPr id="3" name="Shape 0"/>
-          <p:cNvSpPr/>
-          <p:nvPr/>
-        </p:nvSpPr>
-        <p:spPr>
-          <a:xfrm>
-            <a:off x="0" y="0"/>
-            <a:ext cx="4063898" cy="146304"/>
-          </a:xfrm>
-          <a:prstGeom prst="rect">
-            <a:avLst/>
-          </a:prstGeom>
-          <a:solidFill>
-            <a:srgbClr val="0F9E8E"/>
-          </a:solidFill>
-          <a:ln/>
-        </p:spPr>
-        <p:txBody>
-          <a:bodyPr/>
-          <a:lstStyle/>
-          <a:p>
-            <a:endParaRPr lang="LID4096"/>
-          </a:p>
-        </p:txBody>
-      </p:sp>
-      <p:sp>
-        <p:nvSpPr>
-          <p:cNvPr id="4" name="Shape 1"/>
-          <p:cNvSpPr/>
-          <p:nvPr/>
-        </p:nvSpPr>
-        <p:spPr>
-          <a:xfrm>
-            <a:off x="4063898" y="0"/>
-            <a:ext cx="4063898" cy="146304"/>
-          </a:xfrm>
-          <a:prstGeom prst="rect">
-            <a:avLst/>
-          </a:prstGeom>
-          <a:solidFill>
-            <a:srgbClr val="2B3F9E"/>
-          </a:solidFill>
-          <a:ln/>
-        </p:spPr>
-        <p:txBody>
-          <a:bodyPr/>
-          <a:lstStyle/>
-          <a:p>
-            <a:endParaRPr lang="LID4096"/>
-          </a:p>
-        </p:txBody>
-      </p:sp>
-      <p:sp>
-        <p:nvSpPr>
-          <p:cNvPr id="5" name="Shape 2"/>
-          <p:cNvSpPr/>
-          <p:nvPr/>
-        </p:nvSpPr>
-        <p:spPr>
-          <a:xfrm>
-            <a:off x="8127797" y="0"/>
-            <a:ext cx="4063898" cy="146304"/>
-          </a:xfrm>
-          <a:prstGeom prst="rect">
-            <a:avLst/>
-          </a:prstGeom>
-          <a:solidFill>
-            <a:srgbClr val="F5A623"/>
-          </a:solidFill>
-          <a:ln/>
-        </p:spPr>
-        <p:txBody>
-          <a:bodyPr/>
-          <a:lstStyle/>
-          <a:p>
-            <a:endParaRPr lang="LID4096"/>
-          </a:p>
-        </p:txBody>
-      </p:sp>
-      <p:sp>
-        <p:nvSpPr>
-          <p:cNvPr id="6" name="Text 3"/>
-          <p:cNvSpPr/>
-          <p:nvPr/>
-        </p:nvSpPr>
-        <p:spPr>
-          <a:xfrm>
-            <a:off x="822960" y="2468880"/>
-            <a:ext cx="9144000" cy="365760"/>
-          </a:xfrm>
-          <a:prstGeom prst="rect">
-            <a:avLst/>
-          </a:prstGeom>
-          <a:noFill/>
-          <a:ln/>
-        </p:spPr>
-        <p:txBody>
-          <a:bodyPr wrap="square" rtlCol="0" anchor="ctr"/>
-          <a:lstStyle/>
-          <a:p>
-            <a:pPr marL="0" indent="0" algn="l">
-              <a:buNone/>
-            </a:pPr>
-            <a:r>
-              <a:rPr lang="en-US" sz="1300" b="1" kern="0" spc="400" dirty="0">
-                <a:solidFill>
-                  <a:srgbClr val="5EE6D6"/>
-                </a:solidFill>
-                <a:latin typeface="IBM Plex Mono" pitchFamily="34" charset="0"/>
-                <a:ea typeface="IBM Plex Mono" pitchFamily="34" charset="-122"/>
-                <a:cs typeface="IBM Plex Mono" pitchFamily="34" charset="-120"/>
-              </a:rPr>
-              <a:t>THANK YOU</a:t>
-            </a:r>
-            <a:endParaRPr lang="en-US" sz="1300" dirty="0"/>
-          </a:p>
-        </p:txBody>
-      </p:sp>
-      <p:sp>
-        <p:nvSpPr>
-          <p:cNvPr id="7" name="Text 4"/>
-          <p:cNvSpPr/>
-          <p:nvPr/>
-        </p:nvSpPr>
-        <p:spPr>
-          <a:xfrm>
-            <a:off x="786384" y="2926080"/>
-            <a:ext cx="10515600" cy="1005840"/>
-          </a:xfrm>
-          <a:prstGeom prst="rect">
-            <a:avLst/>
-          </a:prstGeom>
-          <a:noFill/>
-          <a:ln/>
-        </p:spPr>
-        <p:txBody>
-          <a:bodyPr wrap="square" rtlCol="0" anchor="ctr"/>
-          <a:lstStyle/>
-          <a:p>
-            <a:pPr marL="0" indent="0" algn="l">
-              <a:buNone/>
-            </a:pPr>
-            <a:r>
-              <a:rPr lang="en-US" sz="4000" b="1" dirty="0">
-                <a:solidFill>
-                  <a:srgbClr val="FFFFFF"/>
-                </a:solidFill>
-                <a:latin typeface="Sora" pitchFamily="34" charset="0"/>
-                <a:ea typeface="Sora" pitchFamily="34" charset="-122"/>
-                <a:cs typeface="Sora" pitchFamily="34" charset="-120"/>
-              </a:rPr>
-              <a:t>Now its up to us to create concrete help for organizations</a:t>
-            </a:r>
-            <a:endParaRPr lang="en-US" sz="4000" dirty="0"/>
-          </a:p>
-        </p:txBody>
-      </p:sp>
-      <p:sp>
-        <p:nvSpPr>
-          <p:cNvPr id="8" name="Text 5"/>
-          <p:cNvSpPr/>
-          <p:nvPr/>
-        </p:nvSpPr>
-        <p:spPr>
-          <a:xfrm>
-            <a:off x="822960" y="6419088"/>
-            <a:ext cx="10515600" cy="274320"/>
-          </a:xfrm>
-          <a:prstGeom prst="rect">
-            <a:avLst/>
-          </a:prstGeom>
-          <a:noFill/>
-          <a:ln/>
-        </p:spPr>
-        <p:txBody>
-          <a:bodyPr wrap="square" rtlCol="0" anchor="ctr"/>
-          <a:lstStyle/>
-          <a:p>
-            <a:pPr marL="0" indent="0" algn="l">
-              <a:buNone/>
-            </a:pPr>
-            <a:r>
-              <a:rPr lang="en-US" sz="900" dirty="0">
-                <a:solidFill>
-                  <a:srgbClr val="A9BCCB"/>
                 </a:solidFill>
                 <a:latin typeface="Inter" pitchFamily="34" charset="0"/>
                 <a:ea typeface="Inter" pitchFamily="34" charset="-122"/>

</xml_diff>